<commit_message>
Adjusted data cleaning pipeline
</commit_message>
<xml_diff>
--- a/Picture data cleaning steps.pptx
+++ b/Picture data cleaning steps.pptx
@@ -5,7 +5,7 @@
     <p:sldMasterId id="2147483648" r:id="rId1"/>
   </p:sldMasterIdLst>
   <p:sldIdLst>
-    <p:sldId id="256" r:id="rId2"/>
+    <p:sldId id="257" r:id="rId2"/>
   </p:sldIdLst>
   <p:sldSz cx="12192000" cy="6858000"/>
   <p:notesSz cx="6858000" cy="9144000"/>
@@ -104,6 +104,11 @@
       </a:defRPr>
     </a:lvl9pPr>
   </p:defaultTextStyle>
+  <p:extLst>
+    <p:ext uri="{EFAFB233-063F-42B5-8137-9DF3F51BA10A}">
+      <p15:sldGuideLst xmlns:p15="http://schemas.microsoft.com/office/powerpoint/2012/main"/>
+    </p:ext>
+  </p:extLst>
 </p:presentation>
 </file>
 
@@ -254,7 +259,7 @@
           <a:p>
             <a:fld id="{E7167C61-B40F-4164-B4A6-0BBC753DBCA2}" type="datetimeFigureOut">
               <a:rPr lang="de-DE" smtClean="0"/>
-              <a:t>23.10.2026</a:t>
+              <a:t>26.10.2026</a:t>
             </a:fld>
             <a:endParaRPr lang="de-DE"/>
           </a:p>
@@ -452,7 +457,7 @@
           <a:p>
             <a:fld id="{E7167C61-B40F-4164-B4A6-0BBC753DBCA2}" type="datetimeFigureOut">
               <a:rPr lang="de-DE" smtClean="0"/>
-              <a:t>23.10.2026</a:t>
+              <a:t>26.10.2026</a:t>
             </a:fld>
             <a:endParaRPr lang="de-DE"/>
           </a:p>
@@ -660,7 +665,7 @@
           <a:p>
             <a:fld id="{E7167C61-B40F-4164-B4A6-0BBC753DBCA2}" type="datetimeFigureOut">
               <a:rPr lang="de-DE" smtClean="0"/>
-              <a:t>23.10.2026</a:t>
+              <a:t>26.10.2026</a:t>
             </a:fld>
             <a:endParaRPr lang="de-DE"/>
           </a:p>
@@ -858,7 +863,7 @@
           <a:p>
             <a:fld id="{E7167C61-B40F-4164-B4A6-0BBC753DBCA2}" type="datetimeFigureOut">
               <a:rPr lang="de-DE" smtClean="0"/>
-              <a:t>23.10.2026</a:t>
+              <a:t>26.10.2026</a:t>
             </a:fld>
             <a:endParaRPr lang="de-DE"/>
           </a:p>
@@ -1133,7 +1138,7 @@
           <a:p>
             <a:fld id="{E7167C61-B40F-4164-B4A6-0BBC753DBCA2}" type="datetimeFigureOut">
               <a:rPr lang="de-DE" smtClean="0"/>
-              <a:t>23.10.2026</a:t>
+              <a:t>26.10.2026</a:t>
             </a:fld>
             <a:endParaRPr lang="de-DE"/>
           </a:p>
@@ -1398,7 +1403,7 @@
           <a:p>
             <a:fld id="{E7167C61-B40F-4164-B4A6-0BBC753DBCA2}" type="datetimeFigureOut">
               <a:rPr lang="de-DE" smtClean="0"/>
-              <a:t>23.10.2026</a:t>
+              <a:t>26.10.2026</a:t>
             </a:fld>
             <a:endParaRPr lang="de-DE"/>
           </a:p>
@@ -1810,7 +1815,7 @@
           <a:p>
             <a:fld id="{E7167C61-B40F-4164-B4A6-0BBC753DBCA2}" type="datetimeFigureOut">
               <a:rPr lang="de-DE" smtClean="0"/>
-              <a:t>23.10.2026</a:t>
+              <a:t>26.10.2026</a:t>
             </a:fld>
             <a:endParaRPr lang="de-DE"/>
           </a:p>
@@ -1951,7 +1956,7 @@
           <a:p>
             <a:fld id="{E7167C61-B40F-4164-B4A6-0BBC753DBCA2}" type="datetimeFigureOut">
               <a:rPr lang="de-DE" smtClean="0"/>
-              <a:t>23.10.2026</a:t>
+              <a:t>26.10.2026</a:t>
             </a:fld>
             <a:endParaRPr lang="de-DE"/>
           </a:p>
@@ -2064,7 +2069,7 @@
           <a:p>
             <a:fld id="{E7167C61-B40F-4164-B4A6-0BBC753DBCA2}" type="datetimeFigureOut">
               <a:rPr lang="de-DE" smtClean="0"/>
-              <a:t>23.10.2026</a:t>
+              <a:t>26.10.2026</a:t>
             </a:fld>
             <a:endParaRPr lang="de-DE"/>
           </a:p>
@@ -2375,7 +2380,7 @@
           <a:p>
             <a:fld id="{E7167C61-B40F-4164-B4A6-0BBC753DBCA2}" type="datetimeFigureOut">
               <a:rPr lang="de-DE" smtClean="0"/>
-              <a:t>23.10.2026</a:t>
+              <a:t>26.10.2026</a:t>
             </a:fld>
             <a:endParaRPr lang="de-DE"/>
           </a:p>
@@ -2663,7 +2668,7 @@
           <a:p>
             <a:fld id="{E7167C61-B40F-4164-B4A6-0BBC753DBCA2}" type="datetimeFigureOut">
               <a:rPr lang="de-DE" smtClean="0"/>
-              <a:t>23.10.2026</a:t>
+              <a:t>26.10.2026</a:t>
             </a:fld>
             <a:endParaRPr lang="de-DE"/>
           </a:p>
@@ -2904,7 +2909,7 @@
           <a:p>
             <a:fld id="{E7167C61-B40F-4164-B4A6-0BBC753DBCA2}" type="datetimeFigureOut">
               <a:rPr lang="de-DE" smtClean="0"/>
-              <a:t>23.10.2026</a:t>
+              <a:t>26.10.2026</a:t>
             </a:fld>
             <a:endParaRPr lang="de-DE"/>
           </a:p>
@@ -3309,7 +3314,13 @@
   <p:cSld>
     <p:spTree>
       <p:nvGrpSpPr>
-        <p:cNvPr id="1" name=""/>
+        <p:cNvPr id="1" name="">
+          <a:extLst>
+            <a:ext uri="{FF2B5EF4-FFF2-40B4-BE49-F238E27FC236}">
+              <a16:creationId xmlns:a16="http://schemas.microsoft.com/office/drawing/2014/main" id="{DCB1D4D9-15CE-5C13-0928-943B3D2CA385}"/>
+            </a:ext>
+          </a:extLst>
+        </p:cNvPr>
         <p:cNvGrpSpPr/>
         <p:nvPr/>
       </p:nvGrpSpPr>
@@ -3323,10 +3334,10 @@
       </p:grpSpPr>
       <p:grpSp>
         <p:nvGrpSpPr>
-          <p:cNvPr id="47" name="Gruppieren 46">
+          <p:cNvPr id="2" name="Gruppieren 1">
             <a:extLst>
               <a:ext uri="{FF2B5EF4-FFF2-40B4-BE49-F238E27FC236}">
-                <a16:creationId xmlns:a16="http://schemas.microsoft.com/office/drawing/2014/main" id="{7F883F60-CD3B-187F-07FA-2E17ACD400A4}"/>
+                <a16:creationId xmlns:a16="http://schemas.microsoft.com/office/drawing/2014/main" id="{74BF453A-0ECF-2B94-A7A2-5E441CAE2EAE}"/>
               </a:ext>
             </a:extLst>
           </p:cNvPr>
@@ -3335,18 +3346,18 @@
         </p:nvGrpSpPr>
         <p:grpSpPr>
           <a:xfrm>
-            <a:off x="768485" y="291829"/>
-            <a:ext cx="8073957" cy="5753912"/>
-            <a:chOff x="768485" y="291829"/>
-            <a:chExt cx="8073957" cy="5753912"/>
+            <a:off x="768485" y="-1632898"/>
+            <a:ext cx="6270482" cy="10069233"/>
+            <a:chOff x="768485" y="-1632898"/>
+            <a:chExt cx="6270482" cy="10069233"/>
           </a:xfrm>
         </p:grpSpPr>
         <p:grpSp>
           <p:nvGrpSpPr>
-            <p:cNvPr id="9" name="Gruppieren 8">
+            <p:cNvPr id="10" name="Gruppieren 9">
               <a:extLst>
                 <a:ext uri="{FF2B5EF4-FFF2-40B4-BE49-F238E27FC236}">
-                  <a16:creationId xmlns:a16="http://schemas.microsoft.com/office/drawing/2014/main" id="{96EDA58E-56B2-1118-D5A3-6D2F56AD5712}"/>
+                  <a16:creationId xmlns:a16="http://schemas.microsoft.com/office/drawing/2014/main" id="{7A3AF09C-7050-DF2E-1818-6DD91E40EB9A}"/>
                 </a:ext>
               </a:extLst>
             </p:cNvPr>
@@ -3355,15 +3366,15 @@
           </p:nvGrpSpPr>
           <p:grpSpPr>
             <a:xfrm>
-              <a:off x="768485" y="291829"/>
-              <a:ext cx="3803515" cy="593388"/>
+              <a:off x="768485" y="-1632898"/>
+              <a:ext cx="6270482" cy="593388"/>
               <a:chOff x="768485" y="291829"/>
               <a:chExt cx="2227633" cy="593388"/>
             </a:xfrm>
             <a:solidFill>
-              <a:schemeClr val="accent4">
-                <a:lumMod val="60000"/>
-                <a:lumOff val="40000"/>
+              <a:schemeClr val="accent1">
+                <a:lumMod val="20000"/>
+                <a:lumOff val="80000"/>
               </a:schemeClr>
             </a:solidFill>
             <a:effectLst>
@@ -3376,10 +3387,10 @@
           </p:grpSpPr>
           <p:sp>
             <p:nvSpPr>
-              <p:cNvPr id="7" name="Rechteck 6">
+              <p:cNvPr id="11" name="Rechteck 10">
                 <a:extLst>
                   <a:ext uri="{FF2B5EF4-FFF2-40B4-BE49-F238E27FC236}">
-                    <a16:creationId xmlns:a16="http://schemas.microsoft.com/office/drawing/2014/main" id="{0E3A4644-5CF1-83AB-58CE-9382CD328B74}"/>
+                    <a16:creationId xmlns:a16="http://schemas.microsoft.com/office/drawing/2014/main" id="{C8D8E736-A8EE-0B76-DF6D-24068E71DB80}"/>
                   </a:ext>
                 </a:extLst>
               </p:cNvPr>
@@ -3435,10 +3446,10 @@
           </p:sp>
           <p:sp>
             <p:nvSpPr>
-              <p:cNvPr id="8" name="Rechteck 7">
+              <p:cNvPr id="12" name="Rechteck 11">
                 <a:extLst>
                   <a:ext uri="{FF2B5EF4-FFF2-40B4-BE49-F238E27FC236}">
-                    <a16:creationId xmlns:a16="http://schemas.microsoft.com/office/drawing/2014/main" id="{2B715861-92AD-0DE0-C420-E2937EC51DE7}"/>
+                    <a16:creationId xmlns:a16="http://schemas.microsoft.com/office/drawing/2014/main" id="{A33C78BB-F5B6-99B7-4CEC-66FB2A0DB5DD}"/>
                   </a:ext>
                 </a:extLst>
               </p:cNvPr>
@@ -3483,30 +3494,36 @@
                     <a:solidFill>
                       <a:schemeClr val="tx1"/>
                     </a:solidFill>
-                    <a:latin typeface="Times New Roman" panose="02020603050405020304" pitchFamily="18" charset="0"/>
-                    <a:cs typeface="Times New Roman" panose="02020603050405020304" pitchFamily="18" charset="0"/>
-                  </a:rPr>
-                  <a:t>Filter </a:t>
+                    <a:cs typeface="Times New Roman" panose="02020603050405020304" pitchFamily="18" charset="0"/>
+                  </a:rPr>
+                  <a:t>Join review </a:t>
                 </a:r>
                 <a:r>
                   <a:rPr lang="de-DE" dirty="0" err="1">
                     <a:solidFill>
                       <a:schemeClr val="tx1"/>
                     </a:solidFill>
-                    <a:latin typeface="Times New Roman" panose="02020603050405020304" pitchFamily="18" charset="0"/>
-                    <a:cs typeface="Times New Roman" panose="02020603050405020304" pitchFamily="18" charset="0"/>
-                  </a:rPr>
-                  <a:t>data</a:t>
+                    <a:cs typeface="Times New Roman" panose="02020603050405020304" pitchFamily="18" charset="0"/>
+                  </a:rPr>
+                  <a:t>titles</a:t>
                 </a:r>
                 <a:r>
                   <a:rPr lang="de-DE" dirty="0">
                     <a:solidFill>
                       <a:schemeClr val="tx1"/>
                     </a:solidFill>
-                    <a:latin typeface="Times New Roman" panose="02020603050405020304" pitchFamily="18" charset="0"/>
-                    <a:cs typeface="Times New Roman" panose="02020603050405020304" pitchFamily="18" charset="0"/>
-                  </a:rPr>
-                  <a:t> by date</a:t>
+                    <a:cs typeface="Times New Roman" panose="02020603050405020304" pitchFamily="18" charset="0"/>
+                  </a:rPr>
+                  <a:t> and </a:t>
+                </a:r>
+                <a:r>
+                  <a:rPr lang="de-DE" dirty="0" err="1">
+                    <a:solidFill>
+                      <a:schemeClr val="tx1"/>
+                    </a:solidFill>
+                    <a:cs typeface="Times New Roman" panose="02020603050405020304" pitchFamily="18" charset="0"/>
+                  </a:rPr>
+                  <a:t>sentences</a:t>
                 </a:r>
                 <a:endParaRPr lang="de-DE" dirty="0">
                   <a:latin typeface="Times New Roman" panose="02020603050405020304" pitchFamily="18" charset="0"/>
@@ -3518,10 +3535,10 @@
         </p:grpSp>
         <p:grpSp>
           <p:nvGrpSpPr>
-            <p:cNvPr id="10" name="Gruppieren 9">
+            <p:cNvPr id="14" name="Gruppieren 13">
               <a:extLst>
                 <a:ext uri="{FF2B5EF4-FFF2-40B4-BE49-F238E27FC236}">
-                  <a16:creationId xmlns:a16="http://schemas.microsoft.com/office/drawing/2014/main" id="{AB443615-50D3-C5D4-91AF-95E32B1D598D}"/>
+                  <a16:creationId xmlns:a16="http://schemas.microsoft.com/office/drawing/2014/main" id="{2820B575-384F-10A5-3AB5-88406A760A38}"/>
                 </a:ext>
               </a:extLst>
             </p:cNvPr>
@@ -3530,15 +3547,15 @@
           </p:nvGrpSpPr>
           <p:grpSpPr>
             <a:xfrm>
-              <a:off x="768485" y="1108952"/>
-              <a:ext cx="3803515" cy="593388"/>
+              <a:off x="768485" y="-888750"/>
+              <a:ext cx="6270482" cy="724714"/>
               <a:chOff x="768485" y="291829"/>
               <a:chExt cx="2227633" cy="593388"/>
             </a:xfrm>
             <a:solidFill>
-              <a:schemeClr val="accent4">
-                <a:lumMod val="60000"/>
-                <a:lumOff val="40000"/>
+              <a:schemeClr val="accent1">
+                <a:lumMod val="20000"/>
+                <a:lumOff val="80000"/>
               </a:schemeClr>
             </a:solidFill>
             <a:effectLst>
@@ -3551,10 +3568,10 @@
           </p:grpSpPr>
           <p:sp>
             <p:nvSpPr>
-              <p:cNvPr id="11" name="Rechteck 10">
+              <p:cNvPr id="15" name="Rechteck 14">
                 <a:extLst>
                   <a:ext uri="{FF2B5EF4-FFF2-40B4-BE49-F238E27FC236}">
-                    <a16:creationId xmlns:a16="http://schemas.microsoft.com/office/drawing/2014/main" id="{9792120B-2B37-18AB-F873-0E57FDB76E32}"/>
+                    <a16:creationId xmlns:a16="http://schemas.microsoft.com/office/drawing/2014/main" id="{871509AC-9ABD-BD68-087A-7FCB2C780808}"/>
                   </a:ext>
                 </a:extLst>
               </p:cNvPr>
@@ -3610,10 +3627,10 @@
           </p:sp>
           <p:sp>
             <p:nvSpPr>
-              <p:cNvPr id="12" name="Rechteck 11">
+              <p:cNvPr id="16" name="Rechteck 15">
                 <a:extLst>
                   <a:ext uri="{FF2B5EF4-FFF2-40B4-BE49-F238E27FC236}">
-                    <a16:creationId xmlns:a16="http://schemas.microsoft.com/office/drawing/2014/main" id="{0D738097-4110-A124-6E00-FA014695B9AA}"/>
+                    <a16:creationId xmlns:a16="http://schemas.microsoft.com/office/drawing/2014/main" id="{642769CD-B186-FF93-F512-2BBC30C79D17}"/>
                   </a:ext>
                 </a:extLst>
               </p:cNvPr>
@@ -3660,7 +3677,7 @@
                     </a:solidFill>
                     <a:cs typeface="Times New Roman" panose="02020603050405020304" pitchFamily="18" charset="0"/>
                   </a:rPr>
-                  <a:t>Join review </a:t>
+                  <a:t>Replace </a:t>
                 </a:r>
                 <a:r>
                   <a:rPr lang="de-DE" dirty="0" err="1">
@@ -3669,7 +3686,7 @@
                     </a:solidFill>
                     <a:cs typeface="Times New Roman" panose="02020603050405020304" pitchFamily="18" charset="0"/>
                   </a:rPr>
-                  <a:t>titles</a:t>
+                  <a:t>emojis</a:t>
                 </a:r>
                 <a:r>
                   <a:rPr lang="de-DE" dirty="0">
@@ -3678,7 +3695,7 @@
                     </a:solidFill>
                     <a:cs typeface="Times New Roman" panose="02020603050405020304" pitchFamily="18" charset="0"/>
                   </a:rPr>
-                  <a:t> and </a:t>
+                  <a:t> by </a:t>
                 </a:r>
                 <a:r>
                   <a:rPr lang="de-DE" dirty="0" err="1">
@@ -3687,10 +3704,75 @@
                     </a:solidFill>
                     <a:cs typeface="Times New Roman" panose="02020603050405020304" pitchFamily="18" charset="0"/>
                   </a:rPr>
-                  <a:t>sentences</a:t>
+                  <a:t>special</a:t>
+                </a:r>
+                <a:r>
+                  <a:rPr lang="de-DE" dirty="0">
+                    <a:solidFill>
+                      <a:schemeClr val="tx1"/>
+                    </a:solidFill>
+                    <a:cs typeface="Times New Roman" panose="02020603050405020304" pitchFamily="18" charset="0"/>
+                  </a:rPr>
+                  <a:t> </a:t>
+                </a:r>
+                <a:r>
+                  <a:rPr lang="de-DE" dirty="0" err="1">
+                    <a:solidFill>
+                      <a:schemeClr val="tx1"/>
+                    </a:solidFill>
+                    <a:cs typeface="Times New Roman" panose="02020603050405020304" pitchFamily="18" charset="0"/>
+                  </a:rPr>
+                  <a:t>keywords</a:t>
                 </a:r>
                 <a:endParaRPr lang="de-DE" dirty="0">
-                  <a:latin typeface="Times New Roman" panose="02020603050405020304" pitchFamily="18" charset="0"/>
+                  <a:solidFill>
+                    <a:schemeClr val="tx1"/>
+                  </a:solidFill>
+                  <a:cs typeface="Times New Roman" panose="02020603050405020304" pitchFamily="18" charset="0"/>
+                </a:endParaRPr>
+              </a:p>
+              <a:p>
+                <a:r>
+                  <a:rPr lang="de-DE" sz="1400" dirty="0">
+                    <a:solidFill>
+                      <a:schemeClr val="tx1"/>
+                    </a:solidFill>
+                    <a:cs typeface="Times New Roman" panose="02020603050405020304" pitchFamily="18" charset="0"/>
+                  </a:rPr>
+                  <a:t>Example: </a:t>
+                </a:r>
+                <a:r>
+                  <a:rPr lang="de-DE" sz="1400" dirty="0"/>
+                  <a:t>👍 </a:t>
+                </a:r>
+                <a:r>
+                  <a:rPr lang="de-DE" sz="1400" dirty="0">
+                    <a:solidFill>
+                      <a:schemeClr val="tx1"/>
+                    </a:solidFill>
+                  </a:rPr>
+                  <a:t>→ :</a:t>
+                </a:r>
+                <a:r>
+                  <a:rPr lang="de-DE" sz="1400" dirty="0" err="1">
+                    <a:solidFill>
+                      <a:schemeClr val="tx1"/>
+                    </a:solidFill>
+                  </a:rPr>
+                  <a:t>thumbs_up</a:t>
+                </a:r>
+                <a:r>
+                  <a:rPr lang="de-DE" sz="1400" dirty="0">
+                    <a:solidFill>
+                      <a:schemeClr val="tx1"/>
+                    </a:solidFill>
+                  </a:rPr>
+                  <a:t>:</a:t>
+                </a:r>
+                <a:endParaRPr lang="de-DE" sz="1400" dirty="0">
+                  <a:solidFill>
+                    <a:schemeClr val="tx1"/>
+                  </a:solidFill>
                   <a:cs typeface="Times New Roman" panose="02020603050405020304" pitchFamily="18" charset="0"/>
                 </a:endParaRPr>
               </a:p>
@@ -3699,10 +3781,10 @@
         </p:grpSp>
         <p:grpSp>
           <p:nvGrpSpPr>
-            <p:cNvPr id="14" name="Gruppieren 13">
+            <p:cNvPr id="17" name="Gruppieren 16">
               <a:extLst>
                 <a:ext uri="{FF2B5EF4-FFF2-40B4-BE49-F238E27FC236}">
-                  <a16:creationId xmlns:a16="http://schemas.microsoft.com/office/drawing/2014/main" id="{82E30044-A1AC-5E3D-7CAB-108046222AFD}"/>
+                  <a16:creationId xmlns:a16="http://schemas.microsoft.com/office/drawing/2014/main" id="{0A241F16-68F1-7C61-5422-F1894F3A9590}"/>
                 </a:ext>
               </a:extLst>
             </p:cNvPr>
@@ -3711,15 +3793,15 @@
           </p:nvGrpSpPr>
           <p:grpSpPr>
             <a:xfrm>
-              <a:off x="768485" y="1896893"/>
-              <a:ext cx="3803515" cy="593388"/>
+              <a:off x="768485" y="-13277"/>
+              <a:ext cx="6270482" cy="724713"/>
               <a:chOff x="768485" y="291829"/>
               <a:chExt cx="2227633" cy="593388"/>
             </a:xfrm>
             <a:solidFill>
-              <a:schemeClr val="accent4">
-                <a:lumMod val="60000"/>
-                <a:lumOff val="40000"/>
+              <a:schemeClr val="accent1">
+                <a:lumMod val="20000"/>
+                <a:lumOff val="80000"/>
               </a:schemeClr>
             </a:solidFill>
             <a:effectLst>
@@ -3732,10 +3814,10 @@
           </p:grpSpPr>
           <p:sp>
             <p:nvSpPr>
-              <p:cNvPr id="15" name="Rechteck 14">
+              <p:cNvPr id="18" name="Rechteck 17">
                 <a:extLst>
                   <a:ext uri="{FF2B5EF4-FFF2-40B4-BE49-F238E27FC236}">
-                    <a16:creationId xmlns:a16="http://schemas.microsoft.com/office/drawing/2014/main" id="{73A633AD-EBCB-F243-7BC8-D956B63D3CE8}"/>
+                    <a16:creationId xmlns:a16="http://schemas.microsoft.com/office/drawing/2014/main" id="{D118D5F9-8889-F10F-E45B-B25A2F0AF80F}"/>
                   </a:ext>
                 </a:extLst>
               </p:cNvPr>
@@ -3791,10 +3873,10 @@
           </p:sp>
           <p:sp>
             <p:nvSpPr>
-              <p:cNvPr id="16" name="Rechteck 15">
+              <p:cNvPr id="19" name="Rechteck 18">
                 <a:extLst>
                   <a:ext uri="{FF2B5EF4-FFF2-40B4-BE49-F238E27FC236}">
-                    <a16:creationId xmlns:a16="http://schemas.microsoft.com/office/drawing/2014/main" id="{10B00896-3005-0046-62A6-7D4C2FE4C606}"/>
+                    <a16:creationId xmlns:a16="http://schemas.microsoft.com/office/drawing/2014/main" id="{E4B97976-76F7-363B-A283-42DF36078604}"/>
                   </a:ext>
                 </a:extLst>
               </p:cNvPr>
@@ -3841,7 +3923,7 @@
                     </a:solidFill>
                     <a:cs typeface="Times New Roman" panose="02020603050405020304" pitchFamily="18" charset="0"/>
                   </a:rPr>
-                  <a:t>Replace </a:t>
+                  <a:t>Drop </a:t>
                 </a:r>
                 <a:r>
                   <a:rPr lang="de-DE" dirty="0" err="1">
@@ -3850,7 +3932,7 @@
                     </a:solidFill>
                     <a:cs typeface="Times New Roman" panose="02020603050405020304" pitchFamily="18" charset="0"/>
                   </a:rPr>
-                  <a:t>emojis</a:t>
+                  <a:t>unimportant</a:t>
                 </a:r>
                 <a:r>
                   <a:rPr lang="de-DE" dirty="0">
@@ -3859,7 +3941,7 @@
                     </a:solidFill>
                     <a:cs typeface="Times New Roman" panose="02020603050405020304" pitchFamily="18" charset="0"/>
                   </a:rPr>
-                  <a:t> by </a:t>
+                  <a:t> </a:t>
                 </a:r>
                 <a:r>
                   <a:rPr lang="de-DE" dirty="0" err="1">
@@ -3868,7 +3950,7 @@
                     </a:solidFill>
                     <a:cs typeface="Times New Roman" panose="02020603050405020304" pitchFamily="18" charset="0"/>
                   </a:rPr>
-                  <a:t>special</a:t>
+                  <a:t>characters</a:t>
                 </a:r>
                 <a:r>
                   <a:rPr lang="de-DE" dirty="0">
@@ -3879,14 +3961,97 @@
                   </a:rPr>
                   <a:t> </a:t>
                 </a:r>
-                <a:r>
-                  <a:rPr lang="de-DE" dirty="0" err="1">
-                    <a:solidFill>
-                      <a:schemeClr val="tx1"/>
-                    </a:solidFill>
-                    <a:cs typeface="Times New Roman" panose="02020603050405020304" pitchFamily="18" charset="0"/>
-                  </a:rPr>
-                  <a:t>keywords</a:t>
+              </a:p>
+              <a:p>
+                <a:r>
+                  <a:rPr lang="de-DE" sz="1400" dirty="0">
+                    <a:solidFill>
+                      <a:schemeClr val="tx1"/>
+                    </a:solidFill>
+                    <a:cs typeface="Times New Roman" panose="02020603050405020304" pitchFamily="18" charset="0"/>
+                  </a:rPr>
+                  <a:t>Example: </a:t>
+                </a:r>
+                <a:r>
+                  <a:rPr lang="de-DE" sz="1400" dirty="0" err="1">
+                    <a:solidFill>
+                      <a:schemeClr val="tx1"/>
+                    </a:solidFill>
+                    <a:cs typeface="Times New Roman" panose="02020603050405020304" pitchFamily="18" charset="0"/>
+                  </a:rPr>
+                  <a:t>excess</a:t>
+                </a:r>
+                <a:r>
+                  <a:rPr lang="de-DE" sz="1400" dirty="0">
+                    <a:solidFill>
+                      <a:schemeClr val="tx1"/>
+                    </a:solidFill>
+                    <a:cs typeface="Times New Roman" panose="02020603050405020304" pitchFamily="18" charset="0"/>
+                  </a:rPr>
+                  <a:t> </a:t>
+                </a:r>
+                <a:r>
+                  <a:rPr lang="de-DE" sz="1400" dirty="0" err="1">
+                    <a:solidFill>
+                      <a:schemeClr val="tx1"/>
+                    </a:solidFill>
+                    <a:cs typeface="Times New Roman" panose="02020603050405020304" pitchFamily="18" charset="0"/>
+                  </a:rPr>
+                  <a:t>whitespace</a:t>
+                </a:r>
+                <a:r>
+                  <a:rPr lang="de-DE" sz="1400" dirty="0">
+                    <a:solidFill>
+                      <a:schemeClr val="tx1"/>
+                    </a:solidFill>
+                    <a:cs typeface="Times New Roman" panose="02020603050405020304" pitchFamily="18" charset="0"/>
+                  </a:rPr>
+                  <a:t>, </a:t>
+                </a:r>
+                <a:r>
+                  <a:rPr lang="de-DE" sz="1400" dirty="0" err="1">
+                    <a:solidFill>
+                      <a:schemeClr val="tx1"/>
+                    </a:solidFill>
+                    <a:cs typeface="Times New Roman" panose="02020603050405020304" pitchFamily="18" charset="0"/>
+                  </a:rPr>
+                  <a:t>numbers</a:t>
+                </a:r>
+                <a:r>
+                  <a:rPr lang="de-DE" sz="1400" dirty="0">
+                    <a:solidFill>
+                      <a:schemeClr val="tx1"/>
+                    </a:solidFill>
+                    <a:cs typeface="Times New Roman" panose="02020603050405020304" pitchFamily="18" charset="0"/>
+                  </a:rPr>
+                  <a:t>, </a:t>
+                </a:r>
+                <a:r>
+                  <a:rPr lang="de-DE" sz="1400" dirty="0" err="1">
+                    <a:solidFill>
+                      <a:schemeClr val="tx1"/>
+                    </a:solidFill>
+                    <a:cs typeface="Times New Roman" panose="02020603050405020304" pitchFamily="18" charset="0"/>
+                  </a:rPr>
+                  <a:t>certain</a:t>
+                </a:r>
+                <a:r>
+                  <a:rPr lang="de-DE" sz="1400" dirty="0">
+                    <a:solidFill>
+                      <a:schemeClr val="tx1"/>
+                    </a:solidFill>
+                    <a:cs typeface="Times New Roman" panose="02020603050405020304" pitchFamily="18" charset="0"/>
+                  </a:rPr>
+                  <a:t> </a:t>
+                </a:r>
+                <a:r>
+                  <a:rPr lang="de-DE" sz="1400" dirty="0" err="1">
+                    <a:solidFill>
+                      <a:schemeClr val="tx1"/>
+                    </a:solidFill>
+                    <a:cs typeface="Times New Roman" panose="02020603050405020304" pitchFamily="18" charset="0"/>
+                  </a:rPr>
+                  <a:t>punctuation</a:t>
                 </a:r>
                 <a:endParaRPr lang="de-DE" dirty="0">
                   <a:latin typeface="Times New Roman" panose="02020603050405020304" pitchFamily="18" charset="0"/>
@@ -3898,10 +4063,10 @@
         </p:grpSp>
         <p:grpSp>
           <p:nvGrpSpPr>
-            <p:cNvPr id="17" name="Gruppieren 16">
+            <p:cNvPr id="20" name="Gruppieren 19">
               <a:extLst>
                 <a:ext uri="{FF2B5EF4-FFF2-40B4-BE49-F238E27FC236}">
-                  <a16:creationId xmlns:a16="http://schemas.microsoft.com/office/drawing/2014/main" id="{530329BE-AB3D-524C-798D-ECE703CF21C9}"/>
+                  <a16:creationId xmlns:a16="http://schemas.microsoft.com/office/drawing/2014/main" id="{2564C555-5F1C-AD5F-0D5B-FABD68C3FAB4}"/>
                 </a:ext>
               </a:extLst>
             </p:cNvPr>
@@ -3910,15 +4075,15 @@
           </p:nvGrpSpPr>
           <p:grpSpPr>
             <a:xfrm>
-              <a:off x="768485" y="2684829"/>
-              <a:ext cx="3803515" cy="1118681"/>
+              <a:off x="768485" y="862194"/>
+              <a:ext cx="6270482" cy="724712"/>
               <a:chOff x="768485" y="291829"/>
               <a:chExt cx="2227633" cy="593388"/>
             </a:xfrm>
             <a:solidFill>
-              <a:schemeClr val="accent4">
-                <a:lumMod val="60000"/>
-                <a:lumOff val="40000"/>
+              <a:schemeClr val="accent1">
+                <a:lumMod val="20000"/>
+                <a:lumOff val="80000"/>
               </a:schemeClr>
             </a:solidFill>
             <a:effectLst>
@@ -3931,10 +4096,10 @@
           </p:grpSpPr>
           <p:sp>
             <p:nvSpPr>
-              <p:cNvPr id="18" name="Rechteck 17">
+              <p:cNvPr id="21" name="Rechteck 20">
                 <a:extLst>
                   <a:ext uri="{FF2B5EF4-FFF2-40B4-BE49-F238E27FC236}">
-                    <a16:creationId xmlns:a16="http://schemas.microsoft.com/office/drawing/2014/main" id="{48C7DA5D-9CC4-206B-DAC8-96B025ADCC30}"/>
+                    <a16:creationId xmlns:a16="http://schemas.microsoft.com/office/drawing/2014/main" id="{01D3C332-B4A8-A9DC-D59A-DAB3C76625B3}"/>
                   </a:ext>
                 </a:extLst>
               </p:cNvPr>
@@ -3990,10 +4155,10 @@
           </p:sp>
           <p:sp>
             <p:nvSpPr>
-              <p:cNvPr id="19" name="Rechteck 18">
+              <p:cNvPr id="22" name="Rechteck 21">
                 <a:extLst>
                   <a:ext uri="{FF2B5EF4-FFF2-40B4-BE49-F238E27FC236}">
-                    <a16:creationId xmlns:a16="http://schemas.microsoft.com/office/drawing/2014/main" id="{290C24EF-E151-9DF2-0BC4-6673351E57B7}"/>
+                    <a16:creationId xmlns:a16="http://schemas.microsoft.com/office/drawing/2014/main" id="{CBC51A37-6067-17B1-E0C2-456682CA073F}"/>
                   </a:ext>
                 </a:extLst>
               </p:cNvPr>
@@ -4040,7 +4205,7 @@
                     </a:solidFill>
                     <a:cs typeface="Times New Roman" panose="02020603050405020304" pitchFamily="18" charset="0"/>
                   </a:rPr>
-                  <a:t>Drop </a:t>
+                  <a:t>Make all </a:t>
                 </a:r>
                 <a:r>
                   <a:rPr lang="de-DE" dirty="0" err="1">
@@ -4049,7 +4214,7 @@
                     </a:solidFill>
                     <a:cs typeface="Times New Roman" panose="02020603050405020304" pitchFamily="18" charset="0"/>
                   </a:rPr>
-                  <a:t>unimportant</a:t>
+                  <a:t>characters</a:t>
                 </a:r>
                 <a:r>
                   <a:rPr lang="de-DE" dirty="0">
@@ -4067,7 +4232,7 @@
                     </a:solidFill>
                     <a:cs typeface="Times New Roman" panose="02020603050405020304" pitchFamily="18" charset="0"/>
                   </a:rPr>
-                  <a:t>characters</a:t>
+                  <a:t>lower</a:t>
                 </a:r>
                 <a:r>
                   <a:rPr lang="de-DE" dirty="0">
@@ -4079,106 +4244,48 @@
                   <a:t> </a:t>
                 </a:r>
                 <a:r>
+                  <a:rPr lang="de-DE" dirty="0" err="1">
+                    <a:solidFill>
+                      <a:schemeClr val="tx1"/>
+                    </a:solidFill>
+                    <a:cs typeface="Times New Roman" panose="02020603050405020304" pitchFamily="18" charset="0"/>
+                  </a:rPr>
+                  <a:t>case</a:t>
+                </a:r>
+                <a:endParaRPr lang="de-DE" dirty="0">
+                  <a:solidFill>
+                    <a:schemeClr val="tx1"/>
+                  </a:solidFill>
+                  <a:cs typeface="Times New Roman" panose="02020603050405020304" pitchFamily="18" charset="0"/>
+                </a:endParaRPr>
+              </a:p>
+              <a:p>
+                <a:r>
                   <a:rPr lang="de-DE" sz="1400" dirty="0">
                     <a:solidFill>
                       <a:schemeClr val="tx1"/>
                     </a:solidFill>
                     <a:cs typeface="Times New Roman" panose="02020603050405020304" pitchFamily="18" charset="0"/>
                   </a:rPr>
-                  <a:t>(e.g. </a:t>
+                  <a:t>Example: Amazon </a:t>
+                </a:r>
+                <a:r>
+                  <a:rPr lang="de-DE" sz="1400" dirty="0">
+                    <a:solidFill>
+                      <a:schemeClr val="tx1"/>
+                    </a:solidFill>
+                  </a:rPr>
+                  <a:t>→ </a:t>
                 </a:r>
                 <a:r>
                   <a:rPr lang="de-DE" sz="1400" dirty="0" err="1">
                     <a:solidFill>
                       <a:schemeClr val="tx1"/>
                     </a:solidFill>
-                    <a:cs typeface="Times New Roman" panose="02020603050405020304" pitchFamily="18" charset="0"/>
-                  </a:rPr>
-                  <a:t>excess</a:t>
-                </a:r>
-                <a:r>
-                  <a:rPr lang="de-DE" sz="1400" dirty="0">
-                    <a:solidFill>
-                      <a:schemeClr val="tx1"/>
-                    </a:solidFill>
-                    <a:cs typeface="Times New Roman" panose="02020603050405020304" pitchFamily="18" charset="0"/>
-                  </a:rPr>
-                  <a:t> </a:t>
-                </a:r>
-                <a:r>
-                  <a:rPr lang="de-DE" sz="1400" dirty="0" err="1">
-                    <a:solidFill>
-                      <a:schemeClr val="tx1"/>
-                    </a:solidFill>
-                    <a:cs typeface="Times New Roman" panose="02020603050405020304" pitchFamily="18" charset="0"/>
-                  </a:rPr>
-                  <a:t>whitespace</a:t>
-                </a:r>
-                <a:r>
-                  <a:rPr lang="de-DE" sz="1400" dirty="0">
-                    <a:solidFill>
-                      <a:schemeClr val="tx1"/>
-                    </a:solidFill>
-                    <a:cs typeface="Times New Roman" panose="02020603050405020304" pitchFamily="18" charset="0"/>
-                  </a:rPr>
-                  <a:t>, </a:t>
-                </a:r>
-                <a:r>
-                  <a:rPr lang="de-DE" sz="1400" dirty="0" err="1">
-                    <a:solidFill>
-                      <a:schemeClr val="tx1"/>
-                    </a:solidFill>
-                    <a:cs typeface="Times New Roman" panose="02020603050405020304" pitchFamily="18" charset="0"/>
-                  </a:rPr>
-                  <a:t>numbers</a:t>
-                </a:r>
-                <a:r>
-                  <a:rPr lang="de-DE" sz="1400" dirty="0">
-                    <a:solidFill>
-                      <a:schemeClr val="tx1"/>
-                    </a:solidFill>
-                    <a:cs typeface="Times New Roman" panose="02020603050405020304" pitchFamily="18" charset="0"/>
-                  </a:rPr>
-                  <a:t>, </a:t>
-                </a:r>
-                <a:r>
-                  <a:rPr lang="de-DE" sz="1400" dirty="0" err="1">
-                    <a:solidFill>
-                      <a:schemeClr val="tx1"/>
-                    </a:solidFill>
-                    <a:cs typeface="Times New Roman" panose="02020603050405020304" pitchFamily="18" charset="0"/>
-                  </a:rPr>
-                  <a:t>certain</a:t>
-                </a:r>
-                <a:r>
-                  <a:rPr lang="de-DE" sz="1400" dirty="0">
-                    <a:solidFill>
-                      <a:schemeClr val="tx1"/>
-                    </a:solidFill>
-                    <a:cs typeface="Times New Roman" panose="02020603050405020304" pitchFamily="18" charset="0"/>
-                  </a:rPr>
-                  <a:t> </a:t>
-                </a:r>
-                <a:r>
-                  <a:rPr lang="de-DE" sz="1400" dirty="0" err="1">
-                    <a:solidFill>
-                      <a:schemeClr val="tx1"/>
-                    </a:solidFill>
-                    <a:cs typeface="Times New Roman" panose="02020603050405020304" pitchFamily="18" charset="0"/>
-                  </a:rPr>
-                  <a:t>punctuation</a:t>
-                </a:r>
-                <a:r>
-                  <a:rPr lang="de-DE" sz="1400" dirty="0">
-                    <a:solidFill>
-                      <a:schemeClr val="tx1"/>
-                    </a:solidFill>
-                    <a:cs typeface="Times New Roman" panose="02020603050405020304" pitchFamily="18" charset="0"/>
-                  </a:rPr>
-                  <a:t>)</a:t>
-                </a:r>
-                <a:endParaRPr lang="de-DE" dirty="0">
-                  <a:latin typeface="Times New Roman" panose="02020603050405020304" pitchFamily="18" charset="0"/>
+                  </a:rPr>
+                  <a:t>amazon</a:t>
+                </a:r>
+                <a:endParaRPr lang="de-DE" sz="1400" dirty="0">
                   <a:cs typeface="Times New Roman" panose="02020603050405020304" pitchFamily="18" charset="0"/>
                 </a:endParaRPr>
               </a:p>
@@ -4187,10 +4294,10 @@
         </p:grpSp>
         <p:grpSp>
           <p:nvGrpSpPr>
-            <p:cNvPr id="20" name="Gruppieren 19">
+            <p:cNvPr id="23" name="Gruppieren 22">
               <a:extLst>
                 <a:ext uri="{FF2B5EF4-FFF2-40B4-BE49-F238E27FC236}">
-                  <a16:creationId xmlns:a16="http://schemas.microsoft.com/office/drawing/2014/main" id="{566E11A5-4416-0EA3-2835-09E949A07111}"/>
+                  <a16:creationId xmlns:a16="http://schemas.microsoft.com/office/drawing/2014/main" id="{800A6A39-B350-CE29-3706-5A3E2B7D8A74}"/>
                 </a:ext>
               </a:extLst>
             </p:cNvPr>
@@ -4199,15 +4306,15 @@
           </p:nvGrpSpPr>
           <p:grpSpPr>
             <a:xfrm>
-              <a:off x="768485" y="3900789"/>
-              <a:ext cx="3803515" cy="593388"/>
+              <a:off x="768485" y="1737662"/>
+              <a:ext cx="6270482" cy="724711"/>
               <a:chOff x="768485" y="291829"/>
               <a:chExt cx="2227633" cy="593388"/>
             </a:xfrm>
             <a:solidFill>
-              <a:schemeClr val="accent4">
-                <a:lumMod val="60000"/>
-                <a:lumOff val="40000"/>
+              <a:schemeClr val="accent1">
+                <a:lumMod val="20000"/>
+                <a:lumOff val="80000"/>
               </a:schemeClr>
             </a:solidFill>
             <a:effectLst>
@@ -4220,10 +4327,10 @@
           </p:grpSpPr>
           <p:sp>
             <p:nvSpPr>
-              <p:cNvPr id="21" name="Rechteck 20">
+              <p:cNvPr id="24" name="Rechteck 23">
                 <a:extLst>
                   <a:ext uri="{FF2B5EF4-FFF2-40B4-BE49-F238E27FC236}">
-                    <a16:creationId xmlns:a16="http://schemas.microsoft.com/office/drawing/2014/main" id="{402A52D3-0297-D4B3-67C1-420A6E65C255}"/>
+                    <a16:creationId xmlns:a16="http://schemas.microsoft.com/office/drawing/2014/main" id="{ABDE24D2-788C-CAE9-8EFC-D1AE594A1BEA}"/>
                   </a:ext>
                 </a:extLst>
               </p:cNvPr>
@@ -4279,10 +4386,10 @@
           </p:sp>
           <p:sp>
             <p:nvSpPr>
-              <p:cNvPr id="22" name="Rechteck 21">
+              <p:cNvPr id="25" name="Rechteck 24">
                 <a:extLst>
                   <a:ext uri="{FF2B5EF4-FFF2-40B4-BE49-F238E27FC236}">
-                    <a16:creationId xmlns:a16="http://schemas.microsoft.com/office/drawing/2014/main" id="{B5A0DEFA-744F-B07B-0F9E-235070A07534}"/>
+                    <a16:creationId xmlns:a16="http://schemas.microsoft.com/office/drawing/2014/main" id="{7402E143-B915-19E6-01A2-9EAAA33AA659}"/>
                   </a:ext>
                 </a:extLst>
               </p:cNvPr>
@@ -4329,7 +4436,7 @@
                     </a:solidFill>
                     <a:cs typeface="Times New Roman" panose="02020603050405020304" pitchFamily="18" charset="0"/>
                   </a:rPr>
-                  <a:t>Make all </a:t>
+                  <a:t>Separate </a:t>
                 </a:r>
                 <a:r>
                   <a:rPr lang="de-DE" dirty="0" err="1">
@@ -4338,10 +4445,53 @@
                     </a:solidFill>
                     <a:cs typeface="Times New Roman" panose="02020603050405020304" pitchFamily="18" charset="0"/>
                   </a:rPr>
-                  <a:t>characters</a:t>
-                </a:r>
-                <a:r>
-                  <a:rPr lang="de-DE" dirty="0">
+                  <a:t>contractions</a:t>
+                </a:r>
+                <a:endParaRPr lang="de-DE" dirty="0">
+                  <a:solidFill>
+                    <a:schemeClr val="tx1"/>
+                  </a:solidFill>
+                  <a:cs typeface="Times New Roman" panose="02020603050405020304" pitchFamily="18" charset="0"/>
+                </a:endParaRPr>
+              </a:p>
+              <a:p>
+                <a:r>
+                  <a:rPr lang="de-DE" sz="1400" dirty="0">
+                    <a:solidFill>
+                      <a:schemeClr val="tx1"/>
+                    </a:solidFill>
+                    <a:cs typeface="Times New Roman" panose="02020603050405020304" pitchFamily="18" charset="0"/>
+                  </a:rPr>
+                  <a:t>Example: </a:t>
+                </a:r>
+                <a:r>
+                  <a:rPr lang="de-DE" sz="1400" dirty="0" err="1">
+                    <a:solidFill>
+                      <a:schemeClr val="tx1"/>
+                    </a:solidFill>
+                    <a:cs typeface="Times New Roman" panose="02020603050405020304" pitchFamily="18" charset="0"/>
+                  </a:rPr>
+                  <a:t>isn</a:t>
+                </a:r>
+                <a:r>
+                  <a:rPr lang="de-DE" sz="1400" dirty="0" err="1">
+                    <a:solidFill>
+                      <a:schemeClr val="tx1"/>
+                    </a:solidFill>
+                  </a:rPr>
+                  <a:t>'</a:t>
+                </a:r>
+                <a:r>
+                  <a:rPr lang="de-DE" sz="1400" dirty="0" err="1">
+                    <a:solidFill>
+                      <a:schemeClr val="tx1"/>
+                    </a:solidFill>
+                    <a:cs typeface="Times New Roman" panose="02020603050405020304" pitchFamily="18" charset="0"/>
+                  </a:rPr>
+                  <a:t>t</a:t>
+                </a:r>
+                <a:r>
+                  <a:rPr lang="de-DE" sz="1400" dirty="0">
                     <a:solidFill>
                       <a:schemeClr val="tx1"/>
                     </a:solidFill>
@@ -4350,34 +4500,30 @@
                   <a:t> </a:t>
                 </a:r>
                 <a:r>
-                  <a:rPr lang="de-DE" dirty="0" err="1">
-                    <a:solidFill>
-                      <a:schemeClr val="tx1"/>
-                    </a:solidFill>
-                    <a:cs typeface="Times New Roman" panose="02020603050405020304" pitchFamily="18" charset="0"/>
-                  </a:rPr>
-                  <a:t>lower</a:t>
-                </a:r>
-                <a:r>
-                  <a:rPr lang="de-DE" dirty="0">
-                    <a:solidFill>
-                      <a:schemeClr val="tx1"/>
-                    </a:solidFill>
-                    <a:cs typeface="Times New Roman" panose="02020603050405020304" pitchFamily="18" charset="0"/>
-                  </a:rPr>
-                  <a:t> </a:t>
-                </a:r>
-                <a:r>
-                  <a:rPr lang="de-DE" dirty="0" err="1">
-                    <a:solidFill>
-                      <a:schemeClr val="tx1"/>
-                    </a:solidFill>
-                    <a:cs typeface="Times New Roman" panose="02020603050405020304" pitchFamily="18" charset="0"/>
-                  </a:rPr>
-                  <a:t>case</a:t>
-                </a:r>
-                <a:endParaRPr lang="de-DE" dirty="0">
-                  <a:latin typeface="Times New Roman" panose="02020603050405020304" pitchFamily="18" charset="0"/>
+                  <a:rPr lang="de-DE" sz="1400" dirty="0">
+                    <a:solidFill>
+                      <a:schemeClr val="tx1"/>
+                    </a:solidFill>
+                  </a:rPr>
+                  <a:t>→ </a:t>
+                </a:r>
+                <a:r>
+                  <a:rPr lang="de-DE" sz="1400" dirty="0" err="1">
+                    <a:solidFill>
+                      <a:schemeClr val="tx1"/>
+                    </a:solidFill>
+                  </a:rPr>
+                  <a:t>is</a:t>
+                </a:r>
+                <a:r>
+                  <a:rPr lang="de-DE" sz="1400" dirty="0">
+                    <a:solidFill>
+                      <a:schemeClr val="tx1"/>
+                    </a:solidFill>
+                  </a:rPr>
+                  <a:t> not</a:t>
+                </a:r>
+                <a:endParaRPr lang="de-DE" sz="1400" dirty="0">
                   <a:cs typeface="Times New Roman" panose="02020603050405020304" pitchFamily="18" charset="0"/>
                 </a:endParaRPr>
               </a:p>
@@ -4386,10 +4532,10 @@
         </p:grpSp>
         <p:grpSp>
           <p:nvGrpSpPr>
-            <p:cNvPr id="23" name="Gruppieren 22">
+            <p:cNvPr id="26" name="Gruppieren 25">
               <a:extLst>
                 <a:ext uri="{FF2B5EF4-FFF2-40B4-BE49-F238E27FC236}">
-                  <a16:creationId xmlns:a16="http://schemas.microsoft.com/office/drawing/2014/main" id="{63E74390-B2B6-5703-38B3-09384F88C95B}"/>
+                  <a16:creationId xmlns:a16="http://schemas.microsoft.com/office/drawing/2014/main" id="{75046D68-9368-831C-3CFA-91B9AFF83B7C}"/>
                 </a:ext>
               </a:extLst>
             </p:cNvPr>
@@ -4398,15 +4544,15 @@
           </p:nvGrpSpPr>
           <p:grpSpPr>
             <a:xfrm>
-              <a:off x="768485" y="4688726"/>
-              <a:ext cx="3803515" cy="593388"/>
+              <a:off x="770163" y="3483845"/>
+              <a:ext cx="6268804" cy="593388"/>
               <a:chOff x="768485" y="291829"/>
               <a:chExt cx="2227633" cy="593388"/>
             </a:xfrm>
             <a:solidFill>
-              <a:schemeClr val="accent4">
-                <a:lumMod val="60000"/>
-                <a:lumOff val="40000"/>
+              <a:schemeClr val="accent1">
+                <a:lumMod val="20000"/>
+                <a:lumOff val="80000"/>
               </a:schemeClr>
             </a:solidFill>
             <a:effectLst>
@@ -4419,10 +4565,10 @@
           </p:grpSpPr>
           <p:sp>
             <p:nvSpPr>
-              <p:cNvPr id="24" name="Rechteck 23">
+              <p:cNvPr id="27" name="Rechteck 26">
                 <a:extLst>
                   <a:ext uri="{FF2B5EF4-FFF2-40B4-BE49-F238E27FC236}">
-                    <a16:creationId xmlns:a16="http://schemas.microsoft.com/office/drawing/2014/main" id="{D7B94A6A-7EDF-F0F8-99BD-392A414A9D6C}"/>
+                    <a16:creationId xmlns:a16="http://schemas.microsoft.com/office/drawing/2014/main" id="{A4D07A7F-F200-E0E6-4955-1CA25982FF63}"/>
                   </a:ext>
                 </a:extLst>
               </p:cNvPr>
@@ -4471,17 +4617,17 @@
                     <a:latin typeface="Times New Roman" panose="02020603050405020304" pitchFamily="18" charset="0"/>
                     <a:cs typeface="Times New Roman" panose="02020603050405020304" pitchFamily="18" charset="0"/>
                   </a:rPr>
-                  <a:t>VI.</a:t>
+                  <a:t>VII.</a:t>
                 </a:r>
               </a:p>
             </p:txBody>
           </p:sp>
           <p:sp>
             <p:nvSpPr>
-              <p:cNvPr id="25" name="Rechteck 24">
+              <p:cNvPr id="28" name="Rechteck 27">
                 <a:extLst>
                   <a:ext uri="{FF2B5EF4-FFF2-40B4-BE49-F238E27FC236}">
-                    <a16:creationId xmlns:a16="http://schemas.microsoft.com/office/drawing/2014/main" id="{934B6CF1-BE78-0137-8E96-D067299DEA20}"/>
+                    <a16:creationId xmlns:a16="http://schemas.microsoft.com/office/drawing/2014/main" id="{40902F85-140F-3A20-8F85-87ABA871F9DC}"/>
                   </a:ext>
                 </a:extLst>
               </p:cNvPr>
@@ -4528,7 +4674,7 @@
                     </a:solidFill>
                     <a:cs typeface="Times New Roman" panose="02020603050405020304" pitchFamily="18" charset="0"/>
                   </a:rPr>
-                  <a:t>Separate </a:t>
+                  <a:t>Correct </a:t>
                 </a:r>
                 <a:r>
                   <a:rPr lang="de-DE" dirty="0" err="1">
@@ -4537,7 +4683,25 @@
                     </a:solidFill>
                     <a:cs typeface="Times New Roman" panose="02020603050405020304" pitchFamily="18" charset="0"/>
                   </a:rPr>
-                  <a:t>contractions</a:t>
+                  <a:t>spelling</a:t>
+                </a:r>
+                <a:r>
+                  <a:rPr lang="de-DE" dirty="0">
+                    <a:solidFill>
+                      <a:schemeClr val="tx1"/>
+                    </a:solidFill>
+                    <a:cs typeface="Times New Roman" panose="02020603050405020304" pitchFamily="18" charset="0"/>
+                  </a:rPr>
+                  <a:t> of </a:t>
+                </a:r>
+                <a:r>
+                  <a:rPr lang="de-DE" dirty="0" err="1">
+                    <a:solidFill>
+                      <a:schemeClr val="tx1"/>
+                    </a:solidFill>
+                    <a:cs typeface="Times New Roman" panose="02020603050405020304" pitchFamily="18" charset="0"/>
+                  </a:rPr>
+                  <a:t>words</a:t>
                 </a:r>
                 <a:endParaRPr lang="de-DE" dirty="0">
                   <a:latin typeface="Times New Roman" panose="02020603050405020304" pitchFamily="18" charset="0"/>
@@ -4549,10 +4713,10 @@
         </p:grpSp>
         <p:grpSp>
           <p:nvGrpSpPr>
-            <p:cNvPr id="26" name="Gruppieren 25">
+            <p:cNvPr id="29" name="Gruppieren 28">
               <a:extLst>
                 <a:ext uri="{FF2B5EF4-FFF2-40B4-BE49-F238E27FC236}">
-                  <a16:creationId xmlns:a16="http://schemas.microsoft.com/office/drawing/2014/main" id="{F0AAD1B4-319D-FB30-1D48-638D3E597F52}"/>
+                  <a16:creationId xmlns:a16="http://schemas.microsoft.com/office/drawing/2014/main" id="{AA42005B-3E70-3486-003D-7820522407E6}"/>
                 </a:ext>
               </a:extLst>
             </p:cNvPr>
@@ -4561,15 +4725,15 @@
           </p:nvGrpSpPr>
           <p:grpSpPr>
             <a:xfrm>
-              <a:off x="5038927" y="4985419"/>
-              <a:ext cx="3803515" cy="593388"/>
+              <a:off x="768485" y="4224343"/>
+              <a:ext cx="6270482" cy="724715"/>
               <a:chOff x="768485" y="291829"/>
               <a:chExt cx="2227633" cy="593388"/>
             </a:xfrm>
             <a:solidFill>
-              <a:schemeClr val="accent4">
-                <a:lumMod val="60000"/>
-                <a:lumOff val="40000"/>
+              <a:schemeClr val="accent1">
+                <a:lumMod val="20000"/>
+                <a:lumOff val="80000"/>
               </a:schemeClr>
             </a:solidFill>
             <a:effectLst>
@@ -4582,10 +4746,10 @@
           </p:grpSpPr>
           <p:sp>
             <p:nvSpPr>
-              <p:cNvPr id="27" name="Rechteck 26">
+              <p:cNvPr id="30" name="Rechteck 29">
                 <a:extLst>
                   <a:ext uri="{FF2B5EF4-FFF2-40B4-BE49-F238E27FC236}">
-                    <a16:creationId xmlns:a16="http://schemas.microsoft.com/office/drawing/2014/main" id="{E07838DC-6196-2A8D-4C31-8D3CEA024B3F}"/>
+                    <a16:creationId xmlns:a16="http://schemas.microsoft.com/office/drawing/2014/main" id="{1D404F27-8D1E-51B8-2BC2-0C9266A7C488}"/>
                   </a:ext>
                 </a:extLst>
               </p:cNvPr>
@@ -4641,10 +4805,10 @@
           </p:sp>
           <p:sp>
             <p:nvSpPr>
-              <p:cNvPr id="28" name="Rechteck 27">
+              <p:cNvPr id="31" name="Rechteck 30">
                 <a:extLst>
                   <a:ext uri="{FF2B5EF4-FFF2-40B4-BE49-F238E27FC236}">
-                    <a16:creationId xmlns:a16="http://schemas.microsoft.com/office/drawing/2014/main" id="{1DCF6390-E135-3F92-AD88-E9FD9CC468C5}"/>
+                    <a16:creationId xmlns:a16="http://schemas.microsoft.com/office/drawing/2014/main" id="{6A1DA535-A1A5-CFB1-3D5B-ADF4A9F521C5}"/>
                   </a:ext>
                 </a:extLst>
               </p:cNvPr>
@@ -4691,7 +4855,7 @@
                     </a:solidFill>
                     <a:cs typeface="Times New Roman" panose="02020603050405020304" pitchFamily="18" charset="0"/>
                   </a:rPr>
-                  <a:t>Correct </a:t>
+                  <a:t>Remove </a:t>
                 </a:r>
                 <a:r>
                   <a:rPr lang="de-DE" dirty="0" err="1">
@@ -4700,10 +4864,141 @@
                     </a:solidFill>
                     <a:cs typeface="Times New Roman" panose="02020603050405020304" pitchFamily="18" charset="0"/>
                   </a:rPr>
-                  <a:t>spelling</a:t>
+                  <a:t>stopwords</a:t>
                 </a:r>
                 <a:endParaRPr lang="de-DE" dirty="0">
-                  <a:latin typeface="Times New Roman" panose="02020603050405020304" pitchFamily="18" charset="0"/>
+                  <a:solidFill>
+                    <a:schemeClr val="tx1"/>
+                  </a:solidFill>
+                  <a:cs typeface="Times New Roman" panose="02020603050405020304" pitchFamily="18" charset="0"/>
+                </a:endParaRPr>
+              </a:p>
+              <a:p>
+                <a:r>
+                  <a:rPr lang="de-DE" sz="1400" dirty="0">
+                    <a:solidFill>
+                      <a:schemeClr val="tx1"/>
+                    </a:solidFill>
+                    <a:cs typeface="Times New Roman" panose="02020603050405020304" pitchFamily="18" charset="0"/>
+                  </a:rPr>
+                  <a:t>Example: [</a:t>
+                </a:r>
+                <a:r>
+                  <a:rPr lang="de-DE" sz="1400" dirty="0">
+                    <a:solidFill>
+                      <a:schemeClr val="tx1"/>
+                    </a:solidFill>
+                  </a:rPr>
+                  <a:t>'</a:t>
+                </a:r>
+                <a:r>
+                  <a:rPr lang="de-DE" sz="1400" dirty="0" err="1">
+                    <a:solidFill>
+                      <a:schemeClr val="tx1"/>
+                    </a:solidFill>
+                  </a:rPr>
+                  <a:t>wine</a:t>
+                </a:r>
+                <a:r>
+                  <a:rPr lang="de-DE" sz="1400" dirty="0">
+                    <a:solidFill>
+                      <a:schemeClr val="tx1"/>
+                    </a:solidFill>
+                  </a:rPr>
+                  <a:t>', 'and', '</a:t>
+                </a:r>
+                <a:r>
+                  <a:rPr lang="de-DE" sz="1400" dirty="0" err="1">
+                    <a:solidFill>
+                      <a:schemeClr val="tx1"/>
+                    </a:solidFill>
+                  </a:rPr>
+                  <a:t>chocolate</a:t>
+                </a:r>
+                <a:r>
+                  <a:rPr lang="de-DE" sz="1400" dirty="0">
+                    <a:solidFill>
+                      <a:schemeClr val="tx1"/>
+                    </a:solidFill>
+                  </a:rPr>
+                  <a:t>‘</a:t>
+                </a:r>
+                <a:r>
+                  <a:rPr lang="de-DE" sz="1400" dirty="0">
+                    <a:solidFill>
+                      <a:schemeClr val="tx1"/>
+                    </a:solidFill>
+                    <a:cs typeface="Times New Roman" panose="02020603050405020304" pitchFamily="18" charset="0"/>
+                  </a:rPr>
+                  <a:t>] </a:t>
+                </a:r>
+                <a:r>
+                  <a:rPr lang="de-DE" sz="1400" dirty="0">
+                    <a:solidFill>
+                      <a:schemeClr val="tx1"/>
+                    </a:solidFill>
+                  </a:rPr>
+                  <a:t>→</a:t>
+                </a:r>
+                <a:r>
+                  <a:rPr lang="de-DE" sz="1400" dirty="0">
+                    <a:solidFill>
+                      <a:schemeClr val="tx1"/>
+                    </a:solidFill>
+                    <a:cs typeface="Times New Roman" panose="02020603050405020304" pitchFamily="18" charset="0"/>
+                  </a:rPr>
+                  <a:t> [</a:t>
+                </a:r>
+                <a:r>
+                  <a:rPr lang="de-DE" sz="1400" dirty="0">
+                    <a:solidFill>
+                      <a:schemeClr val="tx1"/>
+                    </a:solidFill>
+                  </a:rPr>
+                  <a:t>'</a:t>
+                </a:r>
+                <a:r>
+                  <a:rPr lang="de-DE" sz="1400" dirty="0" err="1">
+                    <a:solidFill>
+                      <a:schemeClr val="tx1"/>
+                    </a:solidFill>
+                  </a:rPr>
+                  <a:t>wine</a:t>
+                </a:r>
+                <a:r>
+                  <a:rPr lang="de-DE" sz="1400" dirty="0">
+                    <a:solidFill>
+                      <a:schemeClr val="tx1"/>
+                    </a:solidFill>
+                  </a:rPr>
+                  <a:t>', '</a:t>
+                </a:r>
+                <a:r>
+                  <a:rPr lang="de-DE" sz="1400" dirty="0" err="1">
+                    <a:solidFill>
+                      <a:schemeClr val="tx1"/>
+                    </a:solidFill>
+                  </a:rPr>
+                  <a:t>chocolate</a:t>
+                </a:r>
+                <a:r>
+                  <a:rPr lang="de-DE" sz="1400" dirty="0">
+                    <a:solidFill>
+                      <a:schemeClr val="tx1"/>
+                    </a:solidFill>
+                  </a:rPr>
+                  <a:t>'</a:t>
+                </a:r>
+                <a:r>
+                  <a:rPr lang="de-DE" sz="1400" dirty="0">
+                    <a:solidFill>
+                      <a:schemeClr val="tx1"/>
+                    </a:solidFill>
+                    <a:cs typeface="Times New Roman" panose="02020603050405020304" pitchFamily="18" charset="0"/>
+                  </a:rPr>
+                  <a:t>]</a:t>
+                </a:r>
+                <a:endParaRPr lang="de-DE" dirty="0">
                   <a:cs typeface="Times New Roman" panose="02020603050405020304" pitchFamily="18" charset="0"/>
                 </a:endParaRPr>
               </a:p>
@@ -4712,10 +5007,10 @@
         </p:grpSp>
         <p:grpSp>
           <p:nvGrpSpPr>
-            <p:cNvPr id="29" name="Gruppieren 28">
+            <p:cNvPr id="32" name="Gruppieren 31">
               <a:extLst>
                 <a:ext uri="{FF2B5EF4-FFF2-40B4-BE49-F238E27FC236}">
-                  <a16:creationId xmlns:a16="http://schemas.microsoft.com/office/drawing/2014/main" id="{E6E89043-99EE-64AD-2A70-43532F130F3F}"/>
+                  <a16:creationId xmlns:a16="http://schemas.microsoft.com/office/drawing/2014/main" id="{7EBABE3A-EFEC-D751-DFC8-F1DBEB064293}"/>
                 </a:ext>
               </a:extLst>
             </p:cNvPr>
@@ -4724,15 +5019,15 @@
           </p:nvGrpSpPr>
           <p:grpSpPr>
             <a:xfrm>
-              <a:off x="5038927" y="4197482"/>
-              <a:ext cx="3803515" cy="593388"/>
+              <a:off x="768485" y="5096166"/>
+              <a:ext cx="6270482" cy="724711"/>
               <a:chOff x="768485" y="291829"/>
               <a:chExt cx="2227633" cy="593388"/>
             </a:xfrm>
             <a:solidFill>
-              <a:schemeClr val="accent4">
-                <a:lumMod val="60000"/>
-                <a:lumOff val="40000"/>
+              <a:schemeClr val="accent1">
+                <a:lumMod val="20000"/>
+                <a:lumOff val="80000"/>
               </a:schemeClr>
             </a:solidFill>
             <a:effectLst>
@@ -4745,10 +5040,10 @@
           </p:grpSpPr>
           <p:sp>
             <p:nvSpPr>
-              <p:cNvPr id="30" name="Rechteck 29">
+              <p:cNvPr id="33" name="Rechteck 32">
                 <a:extLst>
                   <a:ext uri="{FF2B5EF4-FFF2-40B4-BE49-F238E27FC236}">
-                    <a16:creationId xmlns:a16="http://schemas.microsoft.com/office/drawing/2014/main" id="{505C1D5F-D40A-9BF4-B7E3-D4C624B4906A}"/>
+                    <a16:creationId xmlns:a16="http://schemas.microsoft.com/office/drawing/2014/main" id="{D0AF9F64-F62B-2036-CDB0-A38BDE2908AA}"/>
                   </a:ext>
                 </a:extLst>
               </p:cNvPr>
@@ -4804,10 +5099,10 @@
           </p:sp>
           <p:sp>
             <p:nvSpPr>
-              <p:cNvPr id="31" name="Rechteck 30">
+              <p:cNvPr id="34" name="Rechteck 33">
                 <a:extLst>
                   <a:ext uri="{FF2B5EF4-FFF2-40B4-BE49-F238E27FC236}">
-                    <a16:creationId xmlns:a16="http://schemas.microsoft.com/office/drawing/2014/main" id="{F19E3624-0884-FC7C-D947-0D5BE7D1EA68}"/>
+                    <a16:creationId xmlns:a16="http://schemas.microsoft.com/office/drawing/2014/main" id="{4E26F630-F99F-3634-9967-9CBB079BC2EF}"/>
                   </a:ext>
                 </a:extLst>
               </p:cNvPr>
@@ -4854,7 +5149,7 @@
                     </a:solidFill>
                     <a:cs typeface="Times New Roman" panose="02020603050405020304" pitchFamily="18" charset="0"/>
                   </a:rPr>
-                  <a:t>Remove </a:t>
+                  <a:t>Word </a:t>
                 </a:r>
                 <a:r>
                   <a:rPr lang="de-DE" dirty="0" err="1">
@@ -4863,10 +5158,69 @@
                     </a:solidFill>
                     <a:cs typeface="Times New Roman" panose="02020603050405020304" pitchFamily="18" charset="0"/>
                   </a:rPr>
-                  <a:t>stopwords</a:t>
+                  <a:t>stemming</a:t>
                 </a:r>
                 <a:endParaRPr lang="de-DE" dirty="0">
-                  <a:latin typeface="Times New Roman" panose="02020603050405020304" pitchFamily="18" charset="0"/>
+                  <a:solidFill>
+                    <a:schemeClr val="tx1"/>
+                  </a:solidFill>
+                  <a:cs typeface="Times New Roman" panose="02020603050405020304" pitchFamily="18" charset="0"/>
+                </a:endParaRPr>
+              </a:p>
+              <a:p>
+                <a:r>
+                  <a:rPr lang="de-DE" sz="1400" dirty="0">
+                    <a:solidFill>
+                      <a:schemeClr val="tx1"/>
+                    </a:solidFill>
+                    <a:cs typeface="Times New Roman" panose="02020603050405020304" pitchFamily="18" charset="0"/>
+                  </a:rPr>
+                  <a:t>Example: </a:t>
+                </a:r>
+                <a:r>
+                  <a:rPr lang="de-DE" sz="1400" dirty="0" err="1">
+                    <a:solidFill>
+                      <a:schemeClr val="tx1"/>
+                    </a:solidFill>
+                    <a:cs typeface="Times New Roman" panose="02020603050405020304" pitchFamily="18" charset="0"/>
+                  </a:rPr>
+                  <a:t>deliveries</a:t>
+                </a:r>
+                <a:r>
+                  <a:rPr lang="de-DE" sz="1400" dirty="0">
+                    <a:solidFill>
+                      <a:schemeClr val="tx1"/>
+                    </a:solidFill>
+                    <a:cs typeface="Times New Roman" panose="02020603050405020304" pitchFamily="18" charset="0"/>
+                  </a:rPr>
+                  <a:t> </a:t>
+                </a:r>
+                <a:r>
+                  <a:rPr lang="de-DE" sz="1400" dirty="0">
+                    <a:solidFill>
+                      <a:schemeClr val="tx1"/>
+                    </a:solidFill>
+                  </a:rPr>
+                  <a:t>→ </a:t>
+                </a:r>
+                <a:r>
+                  <a:rPr lang="de-DE" sz="1400" dirty="0" err="1">
+                    <a:solidFill>
+                      <a:schemeClr val="tx1"/>
+                    </a:solidFill>
+                  </a:rPr>
+                  <a:t>deliveri</a:t>
+                </a:r>
+                <a:r>
+                  <a:rPr lang="de-DE" sz="1400" dirty="0">
+                    <a:solidFill>
+                      <a:schemeClr val="tx1"/>
+                    </a:solidFill>
+                    <a:cs typeface="Times New Roman" panose="02020603050405020304" pitchFamily="18" charset="0"/>
+                  </a:rPr>
+                  <a:t> </a:t>
+                </a:r>
+                <a:endParaRPr lang="de-DE" sz="1400" dirty="0">
                   <a:cs typeface="Times New Roman" panose="02020603050405020304" pitchFamily="18" charset="0"/>
                 </a:endParaRPr>
               </a:p>
@@ -4875,10 +5229,10 @@
         </p:grpSp>
         <p:grpSp>
           <p:nvGrpSpPr>
-            <p:cNvPr id="32" name="Gruppieren 31">
+            <p:cNvPr id="35" name="Gruppieren 34">
               <a:extLst>
                 <a:ext uri="{FF2B5EF4-FFF2-40B4-BE49-F238E27FC236}">
-                  <a16:creationId xmlns:a16="http://schemas.microsoft.com/office/drawing/2014/main" id="{DC52A3DE-06C4-7C32-FDB5-9FC6C494FABC}"/>
+                  <a16:creationId xmlns:a16="http://schemas.microsoft.com/office/drawing/2014/main" id="{8FB7ABAA-F540-B42E-1FCA-36FC298F88F2}"/>
                 </a:ext>
               </a:extLst>
             </p:cNvPr>
@@ -4887,15 +5241,15 @@
           </p:nvGrpSpPr>
           <p:grpSpPr>
             <a:xfrm>
-              <a:off x="5038927" y="3429000"/>
-              <a:ext cx="3803515" cy="593388"/>
+              <a:off x="768485" y="5967984"/>
+              <a:ext cx="6270482" cy="724713"/>
               <a:chOff x="768485" y="291829"/>
               <a:chExt cx="2227633" cy="593388"/>
             </a:xfrm>
             <a:solidFill>
-              <a:schemeClr val="accent4">
-                <a:lumMod val="60000"/>
-                <a:lumOff val="40000"/>
+              <a:schemeClr val="accent1">
+                <a:lumMod val="20000"/>
+                <a:lumOff val="80000"/>
               </a:schemeClr>
             </a:solidFill>
             <a:effectLst>
@@ -4908,10 +5262,10 @@
           </p:grpSpPr>
           <p:sp>
             <p:nvSpPr>
-              <p:cNvPr id="33" name="Rechteck 32">
+              <p:cNvPr id="36" name="Rechteck 35">
                 <a:extLst>
                   <a:ext uri="{FF2B5EF4-FFF2-40B4-BE49-F238E27FC236}">
-                    <a16:creationId xmlns:a16="http://schemas.microsoft.com/office/drawing/2014/main" id="{DD6F868B-6ADA-29B8-8470-8CE8FF514E82}"/>
+                    <a16:creationId xmlns:a16="http://schemas.microsoft.com/office/drawing/2014/main" id="{46B10557-2173-68DC-9FDE-F272AD2A2BC5}"/>
                   </a:ext>
                 </a:extLst>
               </p:cNvPr>
@@ -4967,10 +5321,10 @@
           </p:sp>
           <p:sp>
             <p:nvSpPr>
-              <p:cNvPr id="34" name="Rechteck 33">
+              <p:cNvPr id="37" name="Rechteck 36">
                 <a:extLst>
                   <a:ext uri="{FF2B5EF4-FFF2-40B4-BE49-F238E27FC236}">
-                    <a16:creationId xmlns:a16="http://schemas.microsoft.com/office/drawing/2014/main" id="{F96A0ACA-8149-2174-5F87-E028303C16C6}"/>
+                    <a16:creationId xmlns:a16="http://schemas.microsoft.com/office/drawing/2014/main" id="{901060F7-9C03-4EB4-2724-2BCE9076EC34}"/>
                   </a:ext>
                 </a:extLst>
               </p:cNvPr>
@@ -5017,7 +5371,7 @@
                     </a:solidFill>
                     <a:cs typeface="Times New Roman" panose="02020603050405020304" pitchFamily="18" charset="0"/>
                   </a:rPr>
-                  <a:t>Word </a:t>
+                  <a:t>Join </a:t>
                 </a:r>
                 <a:r>
                   <a:rPr lang="de-DE" dirty="0" err="1">
@@ -5026,10 +5380,127 @@
                     </a:solidFill>
                     <a:cs typeface="Times New Roman" panose="02020603050405020304" pitchFamily="18" charset="0"/>
                   </a:rPr>
-                  <a:t>stemming</a:t>
+                  <a:t>word</a:t>
+                </a:r>
+                <a:r>
+                  <a:rPr lang="de-DE" dirty="0">
+                    <a:solidFill>
+                      <a:schemeClr val="tx1"/>
+                    </a:solidFill>
+                    <a:cs typeface="Times New Roman" panose="02020603050405020304" pitchFamily="18" charset="0"/>
+                  </a:rPr>
+                  <a:t> </a:t>
+                </a:r>
+                <a:r>
+                  <a:rPr lang="de-DE" dirty="0" err="1">
+                    <a:solidFill>
+                      <a:schemeClr val="tx1"/>
+                    </a:solidFill>
+                    <a:cs typeface="Times New Roman" panose="02020603050405020304" pitchFamily="18" charset="0"/>
+                  </a:rPr>
+                  <a:t>stems</a:t>
                 </a:r>
                 <a:endParaRPr lang="de-DE" dirty="0">
-                  <a:latin typeface="Times New Roman" panose="02020603050405020304" pitchFamily="18" charset="0"/>
+                  <a:solidFill>
+                    <a:schemeClr val="tx1"/>
+                  </a:solidFill>
+                  <a:cs typeface="Times New Roman" panose="02020603050405020304" pitchFamily="18" charset="0"/>
+                </a:endParaRPr>
+              </a:p>
+              <a:p>
+                <a:r>
+                  <a:rPr lang="de-DE" sz="1400" dirty="0">
+                    <a:solidFill>
+                      <a:schemeClr val="tx1"/>
+                    </a:solidFill>
+                    <a:cs typeface="Times New Roman" panose="02020603050405020304" pitchFamily="18" charset="0"/>
+                  </a:rPr>
+                  <a:t>Example: [</a:t>
+                </a:r>
+                <a:r>
+                  <a:rPr lang="de-DE" sz="1400" dirty="0">
+                    <a:solidFill>
+                      <a:schemeClr val="tx1"/>
+                    </a:solidFill>
+                  </a:rPr>
+                  <a:t>'</a:t>
+                </a:r>
+                <a:r>
+                  <a:rPr lang="de-DE" sz="1400" dirty="0" err="1">
+                    <a:solidFill>
+                      <a:schemeClr val="tx1"/>
+                    </a:solidFill>
+                  </a:rPr>
+                  <a:t>deliveri</a:t>
+                </a:r>
+                <a:r>
+                  <a:rPr lang="de-DE" sz="1400" dirty="0">
+                    <a:solidFill>
+                      <a:schemeClr val="tx1"/>
+                    </a:solidFill>
+                  </a:rPr>
+                  <a:t>', 'date', 'miss‘</a:t>
+                </a:r>
+                <a:r>
+                  <a:rPr lang="de-DE" sz="1400" dirty="0">
+                    <a:solidFill>
+                      <a:schemeClr val="tx1"/>
+                    </a:solidFill>
+                    <a:cs typeface="Times New Roman" panose="02020603050405020304" pitchFamily="18" charset="0"/>
+                  </a:rPr>
+                  <a:t>] </a:t>
+                </a:r>
+                <a:r>
+                  <a:rPr lang="de-DE" sz="1400" dirty="0">
+                    <a:solidFill>
+                      <a:schemeClr val="tx1"/>
+                    </a:solidFill>
+                  </a:rPr>
+                  <a:t>→</a:t>
+                </a:r>
+                <a:r>
+                  <a:rPr lang="de-DE" sz="1400" dirty="0">
+                    <a:solidFill>
+                      <a:schemeClr val="tx1"/>
+                    </a:solidFill>
+                    <a:cs typeface="Times New Roman" panose="02020603050405020304" pitchFamily="18" charset="0"/>
+                  </a:rPr>
+                  <a:t> [</a:t>
+                </a:r>
+                <a:r>
+                  <a:rPr lang="de-DE" sz="1400" dirty="0">
+                    <a:solidFill>
+                      <a:schemeClr val="tx1"/>
+                    </a:solidFill>
+                  </a:rPr>
+                  <a:t>'</a:t>
+                </a:r>
+                <a:r>
+                  <a:rPr lang="de-DE" sz="1400" dirty="0" err="1">
+                    <a:solidFill>
+                      <a:schemeClr val="tx1"/>
+                    </a:solidFill>
+                  </a:rPr>
+                  <a:t>deliveri</a:t>
+                </a:r>
+                <a:r>
+                  <a:rPr lang="de-DE" sz="1400" dirty="0">
+                    <a:solidFill>
+                      <a:schemeClr val="tx1"/>
+                    </a:solidFill>
+                  </a:rPr>
+                  <a:t> date miss'</a:t>
+                </a:r>
+                <a:r>
+                  <a:rPr lang="de-DE" sz="1400" dirty="0">
+                    <a:solidFill>
+                      <a:schemeClr val="tx1"/>
+                    </a:solidFill>
+                    <a:cs typeface="Times New Roman" panose="02020603050405020304" pitchFamily="18" charset="0"/>
+                  </a:rPr>
+                  <a:t>] </a:t>
+                </a:r>
+                <a:endParaRPr lang="de-DE" sz="1400" dirty="0">
                   <a:cs typeface="Times New Roman" panose="02020603050405020304" pitchFamily="18" charset="0"/>
                 </a:endParaRPr>
               </a:p>
@@ -5038,10 +5509,10 @@
         </p:grpSp>
         <p:grpSp>
           <p:nvGrpSpPr>
-            <p:cNvPr id="35" name="Gruppieren 34">
+            <p:cNvPr id="38" name="Gruppieren 37">
               <a:extLst>
                 <a:ext uri="{FF2B5EF4-FFF2-40B4-BE49-F238E27FC236}">
-                  <a16:creationId xmlns:a16="http://schemas.microsoft.com/office/drawing/2014/main" id="{4528D204-C9E3-92A9-F85B-98A19062A454}"/>
+                  <a16:creationId xmlns:a16="http://schemas.microsoft.com/office/drawing/2014/main" id="{4584F4BD-BB46-356D-2810-284F7A68586D}"/>
                 </a:ext>
               </a:extLst>
             </p:cNvPr>
@@ -5050,15 +5521,15 @@
           </p:nvGrpSpPr>
           <p:grpSpPr>
             <a:xfrm>
-              <a:off x="5038927" y="2611867"/>
-              <a:ext cx="3803515" cy="593388"/>
+              <a:off x="768485" y="2613127"/>
+              <a:ext cx="6270482" cy="724709"/>
               <a:chOff x="768485" y="291829"/>
               <a:chExt cx="2227633" cy="593388"/>
             </a:xfrm>
             <a:solidFill>
-              <a:schemeClr val="accent4">
-                <a:lumMod val="60000"/>
-                <a:lumOff val="40000"/>
+              <a:schemeClr val="accent1">
+                <a:lumMod val="20000"/>
+                <a:lumOff val="80000"/>
               </a:schemeClr>
             </a:solidFill>
             <a:effectLst>
@@ -5071,10 +5542,10 @@
           </p:grpSpPr>
           <p:sp>
             <p:nvSpPr>
-              <p:cNvPr id="36" name="Rechteck 35">
+              <p:cNvPr id="39" name="Rechteck 38">
                 <a:extLst>
                   <a:ext uri="{FF2B5EF4-FFF2-40B4-BE49-F238E27FC236}">
-                    <a16:creationId xmlns:a16="http://schemas.microsoft.com/office/drawing/2014/main" id="{A041F5A8-06C0-3058-3E19-DE71DC2A3E05}"/>
+                    <a16:creationId xmlns:a16="http://schemas.microsoft.com/office/drawing/2014/main" id="{53713B93-A06D-898C-74A2-500F7CFFFE0D}"/>
                   </a:ext>
                 </a:extLst>
               </p:cNvPr>
@@ -5123,17 +5594,17 @@
                     <a:latin typeface="Times New Roman" panose="02020603050405020304" pitchFamily="18" charset="0"/>
                     <a:cs typeface="Times New Roman" panose="02020603050405020304" pitchFamily="18" charset="0"/>
                   </a:rPr>
-                  <a:t>XI.</a:t>
+                  <a:t>VI.</a:t>
                 </a:r>
               </a:p>
             </p:txBody>
           </p:sp>
           <p:sp>
             <p:nvSpPr>
-              <p:cNvPr id="37" name="Rechteck 36">
+              <p:cNvPr id="40" name="Rechteck 39">
                 <a:extLst>
                   <a:ext uri="{FF2B5EF4-FFF2-40B4-BE49-F238E27FC236}">
-                    <a16:creationId xmlns:a16="http://schemas.microsoft.com/office/drawing/2014/main" id="{C75F4A52-483F-6EB6-87BA-9B80E777B642}"/>
+                    <a16:creationId xmlns:a16="http://schemas.microsoft.com/office/drawing/2014/main" id="{26CE7229-6393-FE2B-5767-BFAA425190B9}"/>
                   </a:ext>
                 </a:extLst>
               </p:cNvPr>
@@ -5180,7 +5651,7 @@
                     </a:solidFill>
                     <a:cs typeface="Times New Roman" panose="02020603050405020304" pitchFamily="18" charset="0"/>
                   </a:rPr>
-                  <a:t>Join </a:t>
+                  <a:t>Split into </a:t>
                 </a:r>
                 <a:r>
                   <a:rPr lang="de-DE" dirty="0" err="1">
@@ -5189,25 +5660,107 @@
                     </a:solidFill>
                     <a:cs typeface="Times New Roman" panose="02020603050405020304" pitchFamily="18" charset="0"/>
                   </a:rPr>
-                  <a:t>word</a:t>
-                </a:r>
-                <a:r>
-                  <a:rPr lang="de-DE" dirty="0">
-                    <a:solidFill>
-                      <a:schemeClr val="tx1"/>
-                    </a:solidFill>
-                    <a:cs typeface="Times New Roman" panose="02020603050405020304" pitchFamily="18" charset="0"/>
-                  </a:rPr>
-                  <a:t> </a:t>
-                </a:r>
-                <a:r>
-                  <a:rPr lang="de-DE" dirty="0" err="1">
-                    <a:solidFill>
-                      <a:schemeClr val="tx1"/>
-                    </a:solidFill>
-                    <a:cs typeface="Times New Roman" panose="02020603050405020304" pitchFamily="18" charset="0"/>
-                  </a:rPr>
-                  <a:t>stems</a:t>
+                  <a:t>words</a:t>
+                </a:r>
+                <a:endParaRPr lang="de-DE" dirty="0">
+                  <a:solidFill>
+                    <a:schemeClr val="tx1"/>
+                  </a:solidFill>
+                  <a:cs typeface="Times New Roman" panose="02020603050405020304" pitchFamily="18" charset="0"/>
+                </a:endParaRPr>
+              </a:p>
+              <a:p>
+                <a:r>
+                  <a:rPr lang="de-DE" sz="1400" dirty="0">
+                    <a:solidFill>
+                      <a:schemeClr val="tx1"/>
+                    </a:solidFill>
+                    <a:cs typeface="Times New Roman" panose="02020603050405020304" pitchFamily="18" charset="0"/>
+                  </a:rPr>
+                  <a:t>Example: [</a:t>
+                </a:r>
+                <a:r>
+                  <a:rPr lang="de-DE" sz="1400" dirty="0">
+                    <a:solidFill>
+                      <a:schemeClr val="tx1"/>
+                    </a:solidFill>
+                  </a:rPr>
+                  <a:t>'</a:t>
+                </a:r>
+                <a:r>
+                  <a:rPr lang="de-DE" sz="1400" dirty="0" err="1">
+                    <a:solidFill>
+                      <a:schemeClr val="tx1"/>
+                    </a:solidFill>
+                  </a:rPr>
+                  <a:t>hello</a:t>
+                </a:r>
+                <a:r>
+                  <a:rPr lang="de-DE" sz="1400" dirty="0">
+                    <a:solidFill>
+                      <a:schemeClr val="tx1"/>
+                    </a:solidFill>
+                  </a:rPr>
+                  <a:t> there'</a:t>
+                </a:r>
+                <a:r>
+                  <a:rPr lang="de-DE" sz="1400" dirty="0">
+                    <a:solidFill>
+                      <a:schemeClr val="tx1"/>
+                    </a:solidFill>
+                    <a:cs typeface="Times New Roman" panose="02020603050405020304" pitchFamily="18" charset="0"/>
+                  </a:rPr>
+                  <a:t>]</a:t>
+                </a:r>
+                <a:r>
+                  <a:rPr lang="de-DE" sz="1400" dirty="0">
+                    <a:solidFill>
+                      <a:schemeClr val="tx1"/>
+                    </a:solidFill>
+                  </a:rPr>
+                  <a:t> →</a:t>
+                </a:r>
+                <a:r>
+                  <a:rPr lang="de-DE" sz="1400" dirty="0">
+                    <a:solidFill>
+                      <a:schemeClr val="tx1"/>
+                    </a:solidFill>
+                    <a:cs typeface="Times New Roman" panose="02020603050405020304" pitchFamily="18" charset="0"/>
+                  </a:rPr>
+                  <a:t> [</a:t>
+                </a:r>
+                <a:r>
+                  <a:rPr lang="de-DE" sz="1400" dirty="0">
+                    <a:solidFill>
+                      <a:schemeClr val="tx1"/>
+                    </a:solidFill>
+                  </a:rPr>
+                  <a:t>'</a:t>
+                </a:r>
+                <a:r>
+                  <a:rPr lang="de-DE" sz="1400" dirty="0" err="1">
+                    <a:solidFill>
+                      <a:schemeClr val="tx1"/>
+                    </a:solidFill>
+                  </a:rPr>
+                  <a:t>hello</a:t>
+                </a:r>
+                <a:r>
+                  <a:rPr lang="de-DE" sz="1400" dirty="0">
+                    <a:solidFill>
+                      <a:schemeClr val="tx1"/>
+                    </a:solidFill>
+                  </a:rPr>
+                  <a:t>', 'there'</a:t>
+                </a:r>
+                <a:r>
+                  <a:rPr lang="de-DE" sz="1400" dirty="0">
+                    <a:solidFill>
+                      <a:schemeClr val="tx1"/>
+                    </a:solidFill>
+                    <a:cs typeface="Times New Roman" panose="02020603050405020304" pitchFamily="18" charset="0"/>
+                  </a:rPr>
+                  <a:t>]</a:t>
                 </a:r>
                 <a:endParaRPr lang="de-DE" dirty="0">
                   <a:cs typeface="Times New Roman" panose="02020603050405020304" pitchFamily="18" charset="0"/>
@@ -5218,10 +5771,10 @@
         </p:grpSp>
         <p:grpSp>
           <p:nvGrpSpPr>
-            <p:cNvPr id="38" name="Gruppieren 37">
+            <p:cNvPr id="41" name="Gruppieren 40">
               <a:extLst>
                 <a:ext uri="{FF2B5EF4-FFF2-40B4-BE49-F238E27FC236}">
-                  <a16:creationId xmlns:a16="http://schemas.microsoft.com/office/drawing/2014/main" id="{57003109-4163-8262-F3BA-8ECBEC44C55F}"/>
+                  <a16:creationId xmlns:a16="http://schemas.microsoft.com/office/drawing/2014/main" id="{AB51A291-0162-39D6-70F3-6A6244EE4F8A}"/>
                 </a:ext>
               </a:extLst>
             </p:cNvPr>
@@ -5230,15 +5783,15 @@
           </p:nvGrpSpPr>
           <p:grpSpPr>
             <a:xfrm>
-              <a:off x="768485" y="5452353"/>
-              <a:ext cx="3803515" cy="593388"/>
+              <a:off x="768485" y="6839803"/>
+              <a:ext cx="6270482" cy="724714"/>
               <a:chOff x="768485" y="291829"/>
               <a:chExt cx="2227633" cy="593388"/>
             </a:xfrm>
             <a:solidFill>
-              <a:schemeClr val="accent4">
-                <a:lumMod val="60000"/>
-                <a:lumOff val="40000"/>
+              <a:schemeClr val="accent1">
+                <a:lumMod val="20000"/>
+                <a:lumOff val="80000"/>
               </a:schemeClr>
             </a:solidFill>
             <a:effectLst>
@@ -5251,10 +5804,10 @@
           </p:grpSpPr>
           <p:sp>
             <p:nvSpPr>
-              <p:cNvPr id="39" name="Rechteck 38">
+              <p:cNvPr id="42" name="Rechteck 41">
                 <a:extLst>
                   <a:ext uri="{FF2B5EF4-FFF2-40B4-BE49-F238E27FC236}">
-                    <a16:creationId xmlns:a16="http://schemas.microsoft.com/office/drawing/2014/main" id="{3F8DEE1A-09D8-5A27-8592-DF8A9C793900}"/>
+                    <a16:creationId xmlns:a16="http://schemas.microsoft.com/office/drawing/2014/main" id="{B140C15A-D529-5CB2-FDA7-26A540683669}"/>
                   </a:ext>
                 </a:extLst>
               </p:cNvPr>
@@ -5303,17 +5856,17 @@
                     <a:latin typeface="Times New Roman" panose="02020603050405020304" pitchFamily="18" charset="0"/>
                     <a:cs typeface="Times New Roman" panose="02020603050405020304" pitchFamily="18" charset="0"/>
                   </a:rPr>
-                  <a:t>VII.</a:t>
+                  <a:t>XI.</a:t>
                 </a:r>
               </a:p>
             </p:txBody>
           </p:sp>
           <p:sp>
             <p:nvSpPr>
-              <p:cNvPr id="40" name="Rechteck 39">
+              <p:cNvPr id="43" name="Rechteck 42">
                 <a:extLst>
                   <a:ext uri="{FF2B5EF4-FFF2-40B4-BE49-F238E27FC236}">
-                    <a16:creationId xmlns:a16="http://schemas.microsoft.com/office/drawing/2014/main" id="{B273FBD6-AA4D-7583-A4E2-CE0826CDA3AC}"/>
+                    <a16:creationId xmlns:a16="http://schemas.microsoft.com/office/drawing/2014/main" id="{C9209F77-0A29-377A-C9E6-A5FC3EFB3E9A}"/>
                   </a:ext>
                 </a:extLst>
               </p:cNvPr>
@@ -5360,7 +5913,7 @@
                     </a:solidFill>
                     <a:cs typeface="Times New Roman" panose="02020603050405020304" pitchFamily="18" charset="0"/>
                   </a:rPr>
-                  <a:t>Split into </a:t>
+                  <a:t>Create </a:t>
                 </a:r>
                 <a:r>
                   <a:rPr lang="de-DE" dirty="0" err="1">
@@ -5369,10 +5922,73 @@
                     </a:solidFill>
                     <a:cs typeface="Times New Roman" panose="02020603050405020304" pitchFamily="18" charset="0"/>
                   </a:rPr>
-                  <a:t>words</a:t>
+                  <a:t>star</a:t>
+                </a:r>
+                <a:r>
+                  <a:rPr lang="de-DE" dirty="0">
+                    <a:solidFill>
+                      <a:schemeClr val="tx1"/>
+                    </a:solidFill>
+                    <a:cs typeface="Times New Roman" panose="02020603050405020304" pitchFamily="18" charset="0"/>
+                  </a:rPr>
+                  <a:t> </a:t>
+                </a:r>
+                <a:r>
+                  <a:rPr lang="de-DE" dirty="0" err="1">
+                    <a:solidFill>
+                      <a:schemeClr val="tx1"/>
+                    </a:solidFill>
+                    <a:cs typeface="Times New Roman" panose="02020603050405020304" pitchFamily="18" charset="0"/>
+                  </a:rPr>
+                  <a:t>rating</a:t>
+                </a:r>
+                <a:r>
+                  <a:rPr lang="de-DE" dirty="0">
+                    <a:solidFill>
+                      <a:schemeClr val="tx1"/>
+                    </a:solidFill>
+                    <a:cs typeface="Times New Roman" panose="02020603050405020304" pitchFamily="18" charset="0"/>
+                  </a:rPr>
+                  <a:t> </a:t>
+                </a:r>
+                <a:r>
+                  <a:rPr lang="de-DE" dirty="0" err="1">
+                    <a:solidFill>
+                      <a:schemeClr val="tx1"/>
+                    </a:solidFill>
+                    <a:cs typeface="Times New Roman" panose="02020603050405020304" pitchFamily="18" charset="0"/>
+                  </a:rPr>
+                  <a:t>classes</a:t>
                 </a:r>
                 <a:endParaRPr lang="de-DE" dirty="0">
-                  <a:latin typeface="Times New Roman" panose="02020603050405020304" pitchFamily="18" charset="0"/>
+                  <a:solidFill>
+                    <a:schemeClr val="tx1"/>
+                  </a:solidFill>
+                  <a:cs typeface="Times New Roman" panose="02020603050405020304" pitchFamily="18" charset="0"/>
+                </a:endParaRPr>
+              </a:p>
+              <a:p>
+                <a:r>
+                  <a:rPr lang="de-DE" sz="1400" dirty="0">
+                    <a:solidFill>
+                      <a:schemeClr val="tx1"/>
+                    </a:solidFill>
+                    <a:cs typeface="Times New Roman" panose="02020603050405020304" pitchFamily="18" charset="0"/>
+                  </a:rPr>
+                  <a:t>Example: 2 </a:t>
+                </a:r>
+                <a:r>
+                  <a:rPr lang="de-DE" sz="1400" dirty="0">
+                    <a:solidFill>
+                      <a:schemeClr val="tx1"/>
+                    </a:solidFill>
+                  </a:rPr>
+                  <a:t>→ 'Bad'; 3 → 'Bad'; 5 → 'Good'</a:t>
+                </a:r>
+                <a:endParaRPr lang="de-DE" sz="1400" dirty="0">
+                  <a:solidFill>
+                    <a:schemeClr val="tx1"/>
+                  </a:solidFill>
                   <a:cs typeface="Times New Roman" panose="02020603050405020304" pitchFamily="18" charset="0"/>
                 </a:endParaRPr>
               </a:p>
@@ -5381,10 +5997,10 @@
         </p:grpSp>
         <p:grpSp>
           <p:nvGrpSpPr>
-            <p:cNvPr id="41" name="Gruppieren 40">
+            <p:cNvPr id="44" name="Gruppieren 43">
               <a:extLst>
                 <a:ext uri="{FF2B5EF4-FFF2-40B4-BE49-F238E27FC236}">
-                  <a16:creationId xmlns:a16="http://schemas.microsoft.com/office/drawing/2014/main" id="{F7C4933B-B977-A605-08C0-0AC4014DBE9C}"/>
+                  <a16:creationId xmlns:a16="http://schemas.microsoft.com/office/drawing/2014/main" id="{6A6B7693-2E4D-6EC7-B1D9-7E2EB02D42EA}"/>
                 </a:ext>
               </a:extLst>
             </p:cNvPr>
@@ -5393,15 +6009,15 @@
           </p:nvGrpSpPr>
           <p:grpSpPr>
             <a:xfrm>
-              <a:off x="5038927" y="1804472"/>
-              <a:ext cx="3803515" cy="593388"/>
+              <a:off x="768485" y="7711622"/>
+              <a:ext cx="6270482" cy="724713"/>
               <a:chOff x="768485" y="291829"/>
               <a:chExt cx="2227633" cy="593388"/>
             </a:xfrm>
             <a:solidFill>
-              <a:schemeClr val="accent4">
-                <a:lumMod val="60000"/>
-                <a:lumOff val="40000"/>
+              <a:schemeClr val="accent1">
+                <a:lumMod val="20000"/>
+                <a:lumOff val="80000"/>
               </a:schemeClr>
             </a:solidFill>
             <a:effectLst>
@@ -5414,10 +6030,10 @@
           </p:grpSpPr>
           <p:sp>
             <p:nvSpPr>
-              <p:cNvPr id="42" name="Rechteck 41">
+              <p:cNvPr id="45" name="Rechteck 44">
                 <a:extLst>
                   <a:ext uri="{FF2B5EF4-FFF2-40B4-BE49-F238E27FC236}">
-                    <a16:creationId xmlns:a16="http://schemas.microsoft.com/office/drawing/2014/main" id="{A381E07A-4C7A-8598-0F50-EE0F72841E47}"/>
+                    <a16:creationId xmlns:a16="http://schemas.microsoft.com/office/drawing/2014/main" id="{9B1CF161-ED30-396E-EB9E-45E277D5ED62}"/>
                   </a:ext>
                 </a:extLst>
               </p:cNvPr>
@@ -5473,10 +6089,10 @@
           </p:sp>
           <p:sp>
             <p:nvSpPr>
-              <p:cNvPr id="43" name="Rechteck 42">
+              <p:cNvPr id="46" name="Rechteck 45">
                 <a:extLst>
                   <a:ext uri="{FF2B5EF4-FFF2-40B4-BE49-F238E27FC236}">
-                    <a16:creationId xmlns:a16="http://schemas.microsoft.com/office/drawing/2014/main" id="{52A0325A-6F58-D739-C9CE-88892F092BFE}"/>
+                    <a16:creationId xmlns:a16="http://schemas.microsoft.com/office/drawing/2014/main" id="{E7C78F1C-4592-BEF2-DCB0-EDDB1934A29D}"/>
                   </a:ext>
                 </a:extLst>
               </p:cNvPr>
@@ -5532,211 +6148,6 @@
                     </a:solidFill>
                     <a:cs typeface="Times New Roman" panose="02020603050405020304" pitchFamily="18" charset="0"/>
                   </a:rPr>
-                  <a:t>star</a:t>
-                </a:r>
-                <a:r>
-                  <a:rPr lang="de-DE" dirty="0">
-                    <a:solidFill>
-                      <a:schemeClr val="tx1"/>
-                    </a:solidFill>
-                    <a:cs typeface="Times New Roman" panose="02020603050405020304" pitchFamily="18" charset="0"/>
-                  </a:rPr>
-                  <a:t> </a:t>
-                </a:r>
-                <a:r>
-                  <a:rPr lang="de-DE" dirty="0" err="1">
-                    <a:solidFill>
-                      <a:schemeClr val="tx1"/>
-                    </a:solidFill>
-                    <a:cs typeface="Times New Roman" panose="02020603050405020304" pitchFamily="18" charset="0"/>
-                  </a:rPr>
-                  <a:t>rating</a:t>
-                </a:r>
-                <a:r>
-                  <a:rPr lang="de-DE" dirty="0">
-                    <a:solidFill>
-                      <a:schemeClr val="tx1"/>
-                    </a:solidFill>
-                    <a:cs typeface="Times New Roman" panose="02020603050405020304" pitchFamily="18" charset="0"/>
-                  </a:rPr>
-                  <a:t> </a:t>
-                </a:r>
-                <a:r>
-                  <a:rPr lang="de-DE" dirty="0" err="1">
-                    <a:solidFill>
-                      <a:schemeClr val="tx1"/>
-                    </a:solidFill>
-                    <a:cs typeface="Times New Roman" panose="02020603050405020304" pitchFamily="18" charset="0"/>
-                  </a:rPr>
-                  <a:t>classes</a:t>
-                </a:r>
-                <a:r>
-                  <a:rPr lang="de-DE" dirty="0">
-                    <a:solidFill>
-                      <a:schemeClr val="tx1"/>
-                    </a:solidFill>
-                    <a:latin typeface="Times New Roman" panose="02020603050405020304" pitchFamily="18" charset="0"/>
-                    <a:cs typeface="Times New Roman" panose="02020603050405020304" pitchFamily="18" charset="0"/>
-                  </a:rPr>
-                  <a:t> </a:t>
-                </a:r>
-              </a:p>
-            </p:txBody>
-          </p:sp>
-        </p:grpSp>
-        <p:grpSp>
-          <p:nvGrpSpPr>
-            <p:cNvPr id="44" name="Gruppieren 43">
-              <a:extLst>
-                <a:ext uri="{FF2B5EF4-FFF2-40B4-BE49-F238E27FC236}">
-                  <a16:creationId xmlns:a16="http://schemas.microsoft.com/office/drawing/2014/main" id="{DFF53F5D-D050-2740-A5CD-C06D0AD017B7}"/>
-                </a:ext>
-              </a:extLst>
-            </p:cNvPr>
-            <p:cNvGrpSpPr/>
-            <p:nvPr/>
-          </p:nvGrpSpPr>
-          <p:grpSpPr>
-            <a:xfrm>
-              <a:off x="5038927" y="612843"/>
-              <a:ext cx="3803515" cy="963044"/>
-              <a:chOff x="768485" y="291829"/>
-              <a:chExt cx="2227633" cy="593388"/>
-            </a:xfrm>
-            <a:solidFill>
-              <a:schemeClr val="accent4">
-                <a:lumMod val="60000"/>
-                <a:lumOff val="40000"/>
-              </a:schemeClr>
-            </a:solidFill>
-            <a:effectLst>
-              <a:outerShdw blurRad="50800" dist="38100" dir="2700000" algn="tl" rotWithShape="0">
-                <a:prstClr val="black">
-                  <a:alpha val="40000"/>
-                </a:prstClr>
-              </a:outerShdw>
-            </a:effectLst>
-          </p:grpSpPr>
-          <p:sp>
-            <p:nvSpPr>
-              <p:cNvPr id="45" name="Rechteck 44">
-                <a:extLst>
-                  <a:ext uri="{FF2B5EF4-FFF2-40B4-BE49-F238E27FC236}">
-                    <a16:creationId xmlns:a16="http://schemas.microsoft.com/office/drawing/2014/main" id="{9B97CDB4-ACBC-248C-ECC5-C73A064829EB}"/>
-                  </a:ext>
-                </a:extLst>
-              </p:cNvPr>
-              <p:cNvSpPr/>
-              <p:nvPr/>
-            </p:nvSpPr>
-            <p:spPr>
-              <a:xfrm>
-                <a:off x="768485" y="291830"/>
-                <a:ext cx="515566" cy="593387"/>
-              </a:xfrm>
-              <a:prstGeom prst="rect">
-                <a:avLst/>
-              </a:prstGeom>
-              <a:grpFill/>
-              <a:ln>
-                <a:noFill/>
-              </a:ln>
-            </p:spPr>
-            <p:style>
-              <a:lnRef idx="2">
-                <a:schemeClr val="accent1">
-                  <a:shade val="15000"/>
-                </a:schemeClr>
-              </a:lnRef>
-              <a:fillRef idx="1">
-                <a:schemeClr val="accent1"/>
-              </a:fillRef>
-              <a:effectRef idx="0">
-                <a:schemeClr val="accent1"/>
-              </a:effectRef>
-              <a:fontRef idx="minor">
-                <a:schemeClr val="lt1"/>
-              </a:fontRef>
-            </p:style>
-            <p:txBody>
-              <a:bodyPr rtlCol="0" anchor="ctr"/>
-              <a:lstStyle/>
-              <a:p>
-                <a:pPr algn="ctr"/>
-                <a:r>
-                  <a:rPr lang="de-DE" b="1" dirty="0">
-                    <a:solidFill>
-                      <a:schemeClr val="tx1"/>
-                    </a:solidFill>
-                    <a:latin typeface="Times New Roman" panose="02020603050405020304" pitchFamily="18" charset="0"/>
-                    <a:cs typeface="Times New Roman" panose="02020603050405020304" pitchFamily="18" charset="0"/>
-                  </a:rPr>
-                  <a:t>XIII.</a:t>
-                </a:r>
-              </a:p>
-            </p:txBody>
-          </p:sp>
-          <p:sp>
-            <p:nvSpPr>
-              <p:cNvPr id="46" name="Rechteck 45">
-                <a:extLst>
-                  <a:ext uri="{FF2B5EF4-FFF2-40B4-BE49-F238E27FC236}">
-                    <a16:creationId xmlns:a16="http://schemas.microsoft.com/office/drawing/2014/main" id="{3227FD55-47FF-E4DE-5E99-E3F872834B71}"/>
-                  </a:ext>
-                </a:extLst>
-              </p:cNvPr>
-              <p:cNvSpPr/>
-              <p:nvPr/>
-            </p:nvSpPr>
-            <p:spPr>
-              <a:xfrm>
-                <a:off x="1269459" y="291829"/>
-                <a:ext cx="1726659" cy="593387"/>
-              </a:xfrm>
-              <a:prstGeom prst="rect">
-                <a:avLst/>
-              </a:prstGeom>
-              <a:grpFill/>
-              <a:ln>
-                <a:noFill/>
-              </a:ln>
-            </p:spPr>
-            <p:style>
-              <a:lnRef idx="2">
-                <a:schemeClr val="accent1">
-                  <a:shade val="15000"/>
-                </a:schemeClr>
-              </a:lnRef>
-              <a:fillRef idx="1">
-                <a:schemeClr val="accent1"/>
-              </a:fillRef>
-              <a:effectRef idx="0">
-                <a:schemeClr val="accent1"/>
-              </a:effectRef>
-              <a:fontRef idx="minor">
-                <a:schemeClr val="lt1"/>
-              </a:fontRef>
-            </p:style>
-            <p:txBody>
-              <a:bodyPr rtlCol="0" anchor="ctr"/>
-              <a:lstStyle/>
-              <a:p>
-                <a:r>
-                  <a:rPr lang="de-DE" dirty="0">
-                    <a:solidFill>
-                      <a:schemeClr val="tx1"/>
-                    </a:solidFill>
-                    <a:cs typeface="Times New Roman" panose="02020603050405020304" pitchFamily="18" charset="0"/>
-                  </a:rPr>
-                  <a:t>Create </a:t>
-                </a:r>
-                <a:r>
-                  <a:rPr lang="de-DE" dirty="0" err="1">
-                    <a:solidFill>
-                      <a:schemeClr val="tx1"/>
-                    </a:solidFill>
-                    <a:cs typeface="Times New Roman" panose="02020603050405020304" pitchFamily="18" charset="0"/>
-                  </a:rPr>
                   <a:t>dataset</a:t>
                 </a:r>
                 <a:r>
@@ -5844,7 +6255,7 @@
     </p:spTree>
     <p:extLst>
       <p:ext uri="{BB962C8B-B14F-4D97-AF65-F5344CB8AC3E}">
-        <p14:creationId xmlns:p14="http://schemas.microsoft.com/office/powerpoint/2010/main" val="2166139190"/>
+        <p14:creationId xmlns:p14="http://schemas.microsoft.com/office/powerpoint/2010/main" val="2291621748"/>
       </p:ext>
     </p:extLst>
   </p:cSld>

</xml_diff>

<commit_message>
Adjusted size in figure
</commit_message>
<xml_diff>
--- a/Picture data cleaning steps.pptx
+++ b/Picture data cleaning steps.pptx
@@ -3346,8 +3346,8 @@
         </p:nvGrpSpPr>
         <p:grpSpPr>
           <a:xfrm>
-            <a:off x="768485" y="-1632898"/>
-            <a:ext cx="6270482" cy="10069233"/>
+            <a:off x="768485" y="-1632897"/>
+            <a:ext cx="4968286" cy="6868926"/>
             <a:chOff x="768485" y="-1632898"/>
             <a:chExt cx="6270482" cy="10069233"/>
           </a:xfrm>
@@ -3432,7 +3432,7 @@
               <a:p>
                 <a:pPr algn="ctr"/>
                 <a:r>
-                  <a:rPr lang="de-DE" b="1" dirty="0">
+                  <a:rPr lang="de-DE" sz="1400" b="1" dirty="0">
                     <a:solidFill>
                       <a:schemeClr val="tx1"/>
                     </a:solidFill>
@@ -3490,7 +3490,7 @@
               <a:lstStyle/>
               <a:p>
                 <a:r>
-                  <a:rPr lang="de-DE" dirty="0">
+                  <a:rPr lang="de-DE" sz="1400" dirty="0">
                     <a:solidFill>
                       <a:schemeClr val="tx1"/>
                     </a:solidFill>
@@ -3499,7 +3499,7 @@
                   <a:t>Join review </a:t>
                 </a:r>
                 <a:r>
-                  <a:rPr lang="de-DE" dirty="0" err="1">
+                  <a:rPr lang="de-DE" sz="1400" dirty="0" err="1">
                     <a:solidFill>
                       <a:schemeClr val="tx1"/>
                     </a:solidFill>
@@ -3508,7 +3508,7 @@
                   <a:t>titles</a:t>
                 </a:r>
                 <a:r>
-                  <a:rPr lang="de-DE" dirty="0">
+                  <a:rPr lang="de-DE" sz="1400" dirty="0">
                     <a:solidFill>
                       <a:schemeClr val="tx1"/>
                     </a:solidFill>
@@ -3517,7 +3517,7 @@
                   <a:t> and </a:t>
                 </a:r>
                 <a:r>
-                  <a:rPr lang="de-DE" dirty="0" err="1">
+                  <a:rPr lang="de-DE" sz="1400" dirty="0" err="1">
                     <a:solidFill>
                       <a:schemeClr val="tx1"/>
                     </a:solidFill>
@@ -3525,7 +3525,7 @@
                   </a:rPr>
                   <a:t>sentences</a:t>
                 </a:r>
-                <a:endParaRPr lang="de-DE" dirty="0">
+                <a:endParaRPr lang="de-DE" sz="1400" dirty="0">
                   <a:latin typeface="Times New Roman" panose="02020603050405020304" pitchFamily="18" charset="0"/>
                   <a:cs typeface="Times New Roman" panose="02020603050405020304" pitchFamily="18" charset="0"/>
                 </a:endParaRPr>
@@ -3613,7 +3613,7 @@
               <a:p>
                 <a:pPr algn="ctr"/>
                 <a:r>
-                  <a:rPr lang="de-DE" b="1" dirty="0">
+                  <a:rPr lang="de-DE" sz="1400" b="1" dirty="0">
                     <a:solidFill>
                       <a:schemeClr val="tx1"/>
                     </a:solidFill>
@@ -3671,7 +3671,7 @@
               <a:lstStyle/>
               <a:p>
                 <a:r>
-                  <a:rPr lang="de-DE" dirty="0">
+                  <a:rPr lang="de-DE" sz="1400" dirty="0">
                     <a:solidFill>
                       <a:schemeClr val="tx1"/>
                     </a:solidFill>
@@ -3680,7 +3680,7 @@
                   <a:t>Replace </a:t>
                 </a:r>
                 <a:r>
-                  <a:rPr lang="de-DE" dirty="0" err="1">
+                  <a:rPr lang="de-DE" sz="1400" dirty="0" err="1">
                     <a:solidFill>
                       <a:schemeClr val="tx1"/>
                     </a:solidFill>
@@ -3689,7 +3689,7 @@
                   <a:t>emojis</a:t>
                 </a:r>
                 <a:r>
-                  <a:rPr lang="de-DE" dirty="0">
+                  <a:rPr lang="de-DE" sz="1400" dirty="0">
                     <a:solidFill>
                       <a:schemeClr val="tx1"/>
                     </a:solidFill>
@@ -3698,7 +3698,7 @@
                   <a:t> by </a:t>
                 </a:r>
                 <a:r>
-                  <a:rPr lang="de-DE" dirty="0" err="1">
+                  <a:rPr lang="de-DE" sz="1400" dirty="0" err="1">
                     <a:solidFill>
                       <a:schemeClr val="tx1"/>
                     </a:solidFill>
@@ -3707,7 +3707,7 @@
                   <a:t>special</a:t>
                 </a:r>
                 <a:r>
-                  <a:rPr lang="de-DE" dirty="0">
+                  <a:rPr lang="de-DE" sz="1400" dirty="0">
                     <a:solidFill>
                       <a:schemeClr val="tx1"/>
                     </a:solidFill>
@@ -3716,7 +3716,7 @@
                   <a:t> </a:t>
                 </a:r>
                 <a:r>
-                  <a:rPr lang="de-DE" dirty="0" err="1">
+                  <a:rPr lang="de-DE" sz="1400" dirty="0" err="1">
                     <a:solidFill>
                       <a:schemeClr val="tx1"/>
                     </a:solidFill>
@@ -3724,7 +3724,7 @@
                   </a:rPr>
                   <a:t>keywords</a:t>
                 </a:r>
-                <a:endParaRPr lang="de-DE" dirty="0">
+                <a:endParaRPr lang="de-DE" sz="1400" dirty="0">
                   <a:solidFill>
                     <a:schemeClr val="tx1"/>
                   </a:solidFill>
@@ -3733,7 +3733,7 @@
               </a:p>
               <a:p>
                 <a:r>
-                  <a:rPr lang="de-DE" sz="1400" dirty="0">
+                  <a:rPr lang="de-DE" sz="1100" dirty="0">
                     <a:solidFill>
                       <a:schemeClr val="tx1"/>
                     </a:solidFill>
@@ -3742,11 +3742,11 @@
                   <a:t>Example: </a:t>
                 </a:r>
                 <a:r>
-                  <a:rPr lang="de-DE" sz="1400" dirty="0"/>
+                  <a:rPr lang="de-DE" sz="1100" dirty="0"/>
                   <a:t>👍 </a:t>
                 </a:r>
                 <a:r>
-                  <a:rPr lang="de-DE" sz="1400" dirty="0">
+                  <a:rPr lang="de-DE" sz="1100" dirty="0">
                     <a:solidFill>
                       <a:schemeClr val="tx1"/>
                     </a:solidFill>
@@ -3754,7 +3754,7 @@
                   <a:t>→ :</a:t>
                 </a:r>
                 <a:r>
-                  <a:rPr lang="de-DE" sz="1400" dirty="0" err="1">
+                  <a:rPr lang="de-DE" sz="1100" dirty="0" err="1">
                     <a:solidFill>
                       <a:schemeClr val="tx1"/>
                     </a:solidFill>
@@ -3762,14 +3762,14 @@
                   <a:t>thumbs_up</a:t>
                 </a:r>
                 <a:r>
-                  <a:rPr lang="de-DE" sz="1400" dirty="0">
+                  <a:rPr lang="de-DE" sz="1100" dirty="0">
                     <a:solidFill>
                       <a:schemeClr val="tx1"/>
                     </a:solidFill>
                   </a:rPr>
                   <a:t>:</a:t>
                 </a:r>
-                <a:endParaRPr lang="de-DE" sz="1400" dirty="0">
+                <a:endParaRPr lang="de-DE" sz="1100" dirty="0">
                   <a:solidFill>
                     <a:schemeClr val="tx1"/>
                   </a:solidFill>
@@ -3859,7 +3859,7 @@
               <a:p>
                 <a:pPr algn="ctr"/>
                 <a:r>
-                  <a:rPr lang="de-DE" b="1" dirty="0">
+                  <a:rPr lang="de-DE" sz="1400" b="1" dirty="0">
                     <a:solidFill>
                       <a:schemeClr val="tx1"/>
                     </a:solidFill>
@@ -3917,7 +3917,7 @@
               <a:lstStyle/>
               <a:p>
                 <a:r>
-                  <a:rPr lang="de-DE" dirty="0">
+                  <a:rPr lang="de-DE" sz="1400" dirty="0">
                     <a:solidFill>
                       <a:schemeClr val="tx1"/>
                     </a:solidFill>
@@ -3926,7 +3926,7 @@
                   <a:t>Drop </a:t>
                 </a:r>
                 <a:r>
-                  <a:rPr lang="de-DE" dirty="0" err="1">
+                  <a:rPr lang="de-DE" sz="1400" dirty="0" err="1">
                     <a:solidFill>
                       <a:schemeClr val="tx1"/>
                     </a:solidFill>
@@ -3935,7 +3935,7 @@
                   <a:t>unimportant</a:t>
                 </a:r>
                 <a:r>
-                  <a:rPr lang="de-DE" dirty="0">
+                  <a:rPr lang="de-DE" sz="1400" dirty="0">
                     <a:solidFill>
                       <a:schemeClr val="tx1"/>
                     </a:solidFill>
@@ -3944,7 +3944,7 @@
                   <a:t> </a:t>
                 </a:r>
                 <a:r>
-                  <a:rPr lang="de-DE" dirty="0" err="1">
+                  <a:rPr lang="de-DE" sz="1400" dirty="0" err="1">
                     <a:solidFill>
                       <a:schemeClr val="tx1"/>
                     </a:solidFill>
@@ -3953,7 +3953,7 @@
                   <a:t>characters</a:t>
                 </a:r>
                 <a:r>
-                  <a:rPr lang="de-DE" dirty="0">
+                  <a:rPr lang="de-DE" sz="1400" dirty="0">
                     <a:solidFill>
                       <a:schemeClr val="tx1"/>
                     </a:solidFill>
@@ -3964,7 +3964,7 @@
               </a:p>
               <a:p>
                 <a:r>
-                  <a:rPr lang="de-DE" sz="1400" dirty="0">
+                  <a:rPr lang="de-DE" sz="1100" dirty="0">
                     <a:solidFill>
                       <a:schemeClr val="tx1"/>
                     </a:solidFill>
@@ -3973,7 +3973,7 @@
                   <a:t>Example: </a:t>
                 </a:r>
                 <a:r>
-                  <a:rPr lang="de-DE" sz="1400" dirty="0" err="1">
+                  <a:rPr lang="de-DE" sz="1100" dirty="0" err="1">
                     <a:solidFill>
                       <a:schemeClr val="tx1"/>
                     </a:solidFill>
@@ -3982,7 +3982,7 @@
                   <a:t>excess</a:t>
                 </a:r>
                 <a:r>
-                  <a:rPr lang="de-DE" sz="1400" dirty="0">
+                  <a:rPr lang="de-DE" sz="1100" dirty="0">
                     <a:solidFill>
                       <a:schemeClr val="tx1"/>
                     </a:solidFill>
@@ -3991,7 +3991,7 @@
                   <a:t> </a:t>
                 </a:r>
                 <a:r>
-                  <a:rPr lang="de-DE" sz="1400" dirty="0" err="1">
+                  <a:rPr lang="de-DE" sz="1100" dirty="0" err="1">
                     <a:solidFill>
                       <a:schemeClr val="tx1"/>
                     </a:solidFill>
@@ -4000,7 +4000,7 @@
                   <a:t>whitespace</a:t>
                 </a:r>
                 <a:r>
-                  <a:rPr lang="de-DE" sz="1400" dirty="0">
+                  <a:rPr lang="de-DE" sz="1100" dirty="0">
                     <a:solidFill>
                       <a:schemeClr val="tx1"/>
                     </a:solidFill>
@@ -4009,7 +4009,7 @@
                   <a:t>, </a:t>
                 </a:r>
                 <a:r>
-                  <a:rPr lang="de-DE" sz="1400" dirty="0" err="1">
+                  <a:rPr lang="de-DE" sz="1100" dirty="0" err="1">
                     <a:solidFill>
                       <a:schemeClr val="tx1"/>
                     </a:solidFill>
@@ -4018,7 +4018,7 @@
                   <a:t>numbers</a:t>
                 </a:r>
                 <a:r>
-                  <a:rPr lang="de-DE" sz="1400" dirty="0">
+                  <a:rPr lang="de-DE" sz="1100" dirty="0">
                     <a:solidFill>
                       <a:schemeClr val="tx1"/>
                     </a:solidFill>
@@ -4027,7 +4027,7 @@
                   <a:t>, </a:t>
                 </a:r>
                 <a:r>
-                  <a:rPr lang="de-DE" sz="1400" dirty="0" err="1">
+                  <a:rPr lang="de-DE" sz="1100" dirty="0" err="1">
                     <a:solidFill>
                       <a:schemeClr val="tx1"/>
                     </a:solidFill>
@@ -4036,7 +4036,7 @@
                   <a:t>certain</a:t>
                 </a:r>
                 <a:r>
-                  <a:rPr lang="de-DE" sz="1400" dirty="0">
+                  <a:rPr lang="de-DE" sz="1100" dirty="0">
                     <a:solidFill>
                       <a:schemeClr val="tx1"/>
                     </a:solidFill>
@@ -4045,7 +4045,7 @@
                   <a:t> </a:t>
                 </a:r>
                 <a:r>
-                  <a:rPr lang="de-DE" sz="1400" dirty="0" err="1">
+                  <a:rPr lang="de-DE" sz="1100" dirty="0" err="1">
                     <a:solidFill>
                       <a:schemeClr val="tx1"/>
                     </a:solidFill>
@@ -4053,7 +4053,7 @@
                   </a:rPr>
                   <a:t>punctuation</a:t>
                 </a:r>
-                <a:endParaRPr lang="de-DE" dirty="0">
+                <a:endParaRPr lang="de-DE" sz="1400" dirty="0">
                   <a:latin typeface="Times New Roman" panose="02020603050405020304" pitchFamily="18" charset="0"/>
                   <a:cs typeface="Times New Roman" panose="02020603050405020304" pitchFamily="18" charset="0"/>
                 </a:endParaRPr>
@@ -4141,7 +4141,7 @@
               <a:p>
                 <a:pPr algn="ctr"/>
                 <a:r>
-                  <a:rPr lang="de-DE" b="1" dirty="0">
+                  <a:rPr lang="de-DE" sz="1400" b="1" dirty="0">
                     <a:solidFill>
                       <a:schemeClr val="tx1"/>
                     </a:solidFill>
@@ -4199,7 +4199,7 @@
               <a:lstStyle/>
               <a:p>
                 <a:r>
-                  <a:rPr lang="de-DE" dirty="0">
+                  <a:rPr lang="de-DE" sz="1400" dirty="0">
                     <a:solidFill>
                       <a:schemeClr val="tx1"/>
                     </a:solidFill>
@@ -4208,7 +4208,7 @@
                   <a:t>Make all </a:t>
                 </a:r>
                 <a:r>
-                  <a:rPr lang="de-DE" dirty="0" err="1">
+                  <a:rPr lang="de-DE" sz="1400" dirty="0" err="1">
                     <a:solidFill>
                       <a:schemeClr val="tx1"/>
                     </a:solidFill>
@@ -4217,7 +4217,7 @@
                   <a:t>characters</a:t>
                 </a:r>
                 <a:r>
-                  <a:rPr lang="de-DE" dirty="0">
+                  <a:rPr lang="de-DE" sz="1400" dirty="0">
                     <a:solidFill>
                       <a:schemeClr val="tx1"/>
                     </a:solidFill>
@@ -4226,7 +4226,7 @@
                   <a:t> </a:t>
                 </a:r>
                 <a:r>
-                  <a:rPr lang="de-DE" dirty="0" err="1">
+                  <a:rPr lang="de-DE" sz="1400" dirty="0" err="1">
                     <a:solidFill>
                       <a:schemeClr val="tx1"/>
                     </a:solidFill>
@@ -4235,7 +4235,7 @@
                   <a:t>lower</a:t>
                 </a:r>
                 <a:r>
-                  <a:rPr lang="de-DE" dirty="0">
+                  <a:rPr lang="de-DE" sz="1400" dirty="0">
                     <a:solidFill>
                       <a:schemeClr val="tx1"/>
                     </a:solidFill>
@@ -4244,7 +4244,7 @@
                   <a:t> </a:t>
                 </a:r>
                 <a:r>
-                  <a:rPr lang="de-DE" dirty="0" err="1">
+                  <a:rPr lang="de-DE" sz="1400" dirty="0" err="1">
                     <a:solidFill>
                       <a:schemeClr val="tx1"/>
                     </a:solidFill>
@@ -4252,7 +4252,7 @@
                   </a:rPr>
                   <a:t>case</a:t>
                 </a:r>
-                <a:endParaRPr lang="de-DE" dirty="0">
+                <a:endParaRPr lang="de-DE" sz="1400" dirty="0">
                   <a:solidFill>
                     <a:schemeClr val="tx1"/>
                   </a:solidFill>
@@ -4261,7 +4261,7 @@
               </a:p>
               <a:p>
                 <a:r>
-                  <a:rPr lang="de-DE" sz="1400" dirty="0">
+                  <a:rPr lang="de-DE" sz="1100" dirty="0">
                     <a:solidFill>
                       <a:schemeClr val="tx1"/>
                     </a:solidFill>
@@ -4270,7 +4270,7 @@
                   <a:t>Example: Amazon </a:t>
                 </a:r>
                 <a:r>
-                  <a:rPr lang="de-DE" sz="1400" dirty="0">
+                  <a:rPr lang="de-DE" sz="1100" dirty="0">
                     <a:solidFill>
                       <a:schemeClr val="tx1"/>
                     </a:solidFill>
@@ -4278,14 +4278,14 @@
                   <a:t>→ </a:t>
                 </a:r>
                 <a:r>
-                  <a:rPr lang="de-DE" sz="1400" dirty="0" err="1">
+                  <a:rPr lang="de-DE" sz="1100" dirty="0" err="1">
                     <a:solidFill>
                       <a:schemeClr val="tx1"/>
                     </a:solidFill>
                   </a:rPr>
                   <a:t>amazon</a:t>
                 </a:r>
-                <a:endParaRPr lang="de-DE" sz="1400" dirty="0">
+                <a:endParaRPr lang="de-DE" sz="1100" dirty="0">
                   <a:cs typeface="Times New Roman" panose="02020603050405020304" pitchFamily="18" charset="0"/>
                 </a:endParaRPr>
               </a:p>
@@ -4372,7 +4372,7 @@
               <a:p>
                 <a:pPr algn="ctr"/>
                 <a:r>
-                  <a:rPr lang="de-DE" b="1" dirty="0">
+                  <a:rPr lang="de-DE" sz="1400" b="1" dirty="0">
                     <a:solidFill>
                       <a:schemeClr val="tx1"/>
                     </a:solidFill>
@@ -4430,7 +4430,7 @@
               <a:lstStyle/>
               <a:p>
                 <a:r>
-                  <a:rPr lang="de-DE" dirty="0">
+                  <a:rPr lang="de-DE" sz="1400" dirty="0">
                     <a:solidFill>
                       <a:schemeClr val="tx1"/>
                     </a:solidFill>
@@ -4439,7 +4439,7 @@
                   <a:t>Separate </a:t>
                 </a:r>
                 <a:r>
-                  <a:rPr lang="de-DE" dirty="0" err="1">
+                  <a:rPr lang="de-DE" sz="1400" dirty="0" err="1">
                     <a:solidFill>
                       <a:schemeClr val="tx1"/>
                     </a:solidFill>
@@ -4447,7 +4447,7 @@
                   </a:rPr>
                   <a:t>contractions</a:t>
                 </a:r>
-                <a:endParaRPr lang="de-DE" dirty="0">
+                <a:endParaRPr lang="de-DE" sz="1400" dirty="0">
                   <a:solidFill>
                     <a:schemeClr val="tx1"/>
                   </a:solidFill>
@@ -4456,7 +4456,7 @@
               </a:p>
               <a:p>
                 <a:r>
-                  <a:rPr lang="de-DE" sz="1400" dirty="0">
+                  <a:rPr lang="de-DE" sz="1100" dirty="0">
                     <a:solidFill>
                       <a:schemeClr val="tx1"/>
                     </a:solidFill>
@@ -4465,7 +4465,7 @@
                   <a:t>Example: </a:t>
                 </a:r>
                 <a:r>
-                  <a:rPr lang="de-DE" sz="1400" dirty="0" err="1">
+                  <a:rPr lang="de-DE" sz="1100" dirty="0" err="1">
                     <a:solidFill>
                       <a:schemeClr val="tx1"/>
                     </a:solidFill>
@@ -4474,7 +4474,7 @@
                   <a:t>isn</a:t>
                 </a:r>
                 <a:r>
-                  <a:rPr lang="de-DE" sz="1400" dirty="0" err="1">
+                  <a:rPr lang="de-DE" sz="1100" dirty="0" err="1">
                     <a:solidFill>
                       <a:schemeClr val="tx1"/>
                     </a:solidFill>
@@ -4482,7 +4482,7 @@
                   <a:t>'</a:t>
                 </a:r>
                 <a:r>
-                  <a:rPr lang="de-DE" sz="1400" dirty="0" err="1">
+                  <a:rPr lang="de-DE" sz="1100" dirty="0" err="1">
                     <a:solidFill>
                       <a:schemeClr val="tx1"/>
                     </a:solidFill>
@@ -4491,7 +4491,7 @@
                   <a:t>t</a:t>
                 </a:r>
                 <a:r>
-                  <a:rPr lang="de-DE" sz="1400" dirty="0">
+                  <a:rPr lang="de-DE" sz="1100" dirty="0">
                     <a:solidFill>
                       <a:schemeClr val="tx1"/>
                     </a:solidFill>
@@ -4500,7 +4500,7 @@
                   <a:t> </a:t>
                 </a:r>
                 <a:r>
-                  <a:rPr lang="de-DE" sz="1400" dirty="0">
+                  <a:rPr lang="de-DE" sz="1100" dirty="0">
                     <a:solidFill>
                       <a:schemeClr val="tx1"/>
                     </a:solidFill>
@@ -4508,7 +4508,7 @@
                   <a:t>→ </a:t>
                 </a:r>
                 <a:r>
-                  <a:rPr lang="de-DE" sz="1400" dirty="0" err="1">
+                  <a:rPr lang="de-DE" sz="1100" dirty="0" err="1">
                     <a:solidFill>
                       <a:schemeClr val="tx1"/>
                     </a:solidFill>
@@ -4516,14 +4516,14 @@
                   <a:t>is</a:t>
                 </a:r>
                 <a:r>
-                  <a:rPr lang="de-DE" sz="1400" dirty="0">
+                  <a:rPr lang="de-DE" sz="1100" dirty="0">
                     <a:solidFill>
                       <a:schemeClr val="tx1"/>
                     </a:solidFill>
                   </a:rPr>
                   <a:t> not</a:t>
                 </a:r>
-                <a:endParaRPr lang="de-DE" sz="1400" dirty="0">
+                <a:endParaRPr lang="de-DE" sz="1100" dirty="0">
                   <a:cs typeface="Times New Roman" panose="02020603050405020304" pitchFamily="18" charset="0"/>
                 </a:endParaRPr>
               </a:p>
@@ -4610,7 +4610,7 @@
               <a:p>
                 <a:pPr algn="ctr"/>
                 <a:r>
-                  <a:rPr lang="de-DE" b="1" dirty="0">
+                  <a:rPr lang="de-DE" sz="1400" b="1" dirty="0">
                     <a:solidFill>
                       <a:schemeClr val="tx1"/>
                     </a:solidFill>
@@ -4668,7 +4668,7 @@
               <a:lstStyle/>
               <a:p>
                 <a:r>
-                  <a:rPr lang="de-DE" dirty="0">
+                  <a:rPr lang="de-DE" sz="1400" dirty="0">
                     <a:solidFill>
                       <a:schemeClr val="tx1"/>
                     </a:solidFill>
@@ -4677,7 +4677,7 @@
                   <a:t>Correct </a:t>
                 </a:r>
                 <a:r>
-                  <a:rPr lang="de-DE" dirty="0" err="1">
+                  <a:rPr lang="de-DE" sz="1400" dirty="0" err="1">
                     <a:solidFill>
                       <a:schemeClr val="tx1"/>
                     </a:solidFill>
@@ -4686,7 +4686,7 @@
                   <a:t>spelling</a:t>
                 </a:r>
                 <a:r>
-                  <a:rPr lang="de-DE" dirty="0">
+                  <a:rPr lang="de-DE" sz="1400" dirty="0">
                     <a:solidFill>
                       <a:schemeClr val="tx1"/>
                     </a:solidFill>
@@ -4695,7 +4695,7 @@
                   <a:t> of </a:t>
                 </a:r>
                 <a:r>
-                  <a:rPr lang="de-DE" dirty="0" err="1">
+                  <a:rPr lang="de-DE" sz="1400" dirty="0" err="1">
                     <a:solidFill>
                       <a:schemeClr val="tx1"/>
                     </a:solidFill>
@@ -4703,7 +4703,7 @@
                   </a:rPr>
                   <a:t>words</a:t>
                 </a:r>
-                <a:endParaRPr lang="de-DE" dirty="0">
+                <a:endParaRPr lang="de-DE" sz="1400" dirty="0">
                   <a:latin typeface="Times New Roman" panose="02020603050405020304" pitchFamily="18" charset="0"/>
                   <a:cs typeface="Times New Roman" panose="02020603050405020304" pitchFamily="18" charset="0"/>
                 </a:endParaRPr>
@@ -4791,7 +4791,7 @@
               <a:p>
                 <a:pPr algn="ctr"/>
                 <a:r>
-                  <a:rPr lang="de-DE" b="1" dirty="0">
+                  <a:rPr lang="de-DE" sz="1400" b="1" dirty="0">
                     <a:solidFill>
                       <a:schemeClr val="tx1"/>
                     </a:solidFill>
@@ -4849,7 +4849,7 @@
               <a:lstStyle/>
               <a:p>
                 <a:r>
-                  <a:rPr lang="de-DE" dirty="0">
+                  <a:rPr lang="de-DE" sz="1400" dirty="0">
                     <a:solidFill>
                       <a:schemeClr val="tx1"/>
                     </a:solidFill>
@@ -4858,7 +4858,7 @@
                   <a:t>Remove </a:t>
                 </a:r>
                 <a:r>
-                  <a:rPr lang="de-DE" dirty="0" err="1">
+                  <a:rPr lang="de-DE" sz="1400" dirty="0" err="1">
                     <a:solidFill>
                       <a:schemeClr val="tx1"/>
                     </a:solidFill>
@@ -4866,7 +4866,7 @@
                   </a:rPr>
                   <a:t>stopwords</a:t>
                 </a:r>
-                <a:endParaRPr lang="de-DE" dirty="0">
+                <a:endParaRPr lang="de-DE" sz="1400" dirty="0">
                   <a:solidFill>
                     <a:schemeClr val="tx1"/>
                   </a:solidFill>
@@ -4875,7 +4875,7 @@
               </a:p>
               <a:p>
                 <a:r>
-                  <a:rPr lang="de-DE" sz="1400" dirty="0">
+                  <a:rPr lang="de-DE" sz="1100" dirty="0">
                     <a:solidFill>
                       <a:schemeClr val="tx1"/>
                     </a:solidFill>
@@ -4884,7 +4884,7 @@
                   <a:t>Example: [</a:t>
                 </a:r>
                 <a:r>
-                  <a:rPr lang="de-DE" sz="1400" dirty="0">
+                  <a:rPr lang="de-DE" sz="1100" dirty="0">
                     <a:solidFill>
                       <a:schemeClr val="tx1"/>
                     </a:solidFill>
@@ -4892,7 +4892,7 @@
                   <a:t>'</a:t>
                 </a:r>
                 <a:r>
-                  <a:rPr lang="de-DE" sz="1400" dirty="0" err="1">
+                  <a:rPr lang="de-DE" sz="1100" dirty="0" err="1">
                     <a:solidFill>
                       <a:schemeClr val="tx1"/>
                     </a:solidFill>
@@ -4900,7 +4900,7 @@
                   <a:t>wine</a:t>
                 </a:r>
                 <a:r>
-                  <a:rPr lang="de-DE" sz="1400" dirty="0">
+                  <a:rPr lang="de-DE" sz="1100" dirty="0">
                     <a:solidFill>
                       <a:schemeClr val="tx1"/>
                     </a:solidFill>
@@ -4908,7 +4908,7 @@
                   <a:t>', 'and', '</a:t>
                 </a:r>
                 <a:r>
-                  <a:rPr lang="de-DE" sz="1400" dirty="0" err="1">
+                  <a:rPr lang="de-DE" sz="1100" dirty="0" err="1">
                     <a:solidFill>
                       <a:schemeClr val="tx1"/>
                     </a:solidFill>
@@ -4916,7 +4916,7 @@
                   <a:t>chocolate</a:t>
                 </a:r>
                 <a:r>
-                  <a:rPr lang="de-DE" sz="1400" dirty="0">
+                  <a:rPr lang="de-DE" sz="1100" dirty="0">
                     <a:solidFill>
                       <a:schemeClr val="tx1"/>
                     </a:solidFill>
@@ -4924,7 +4924,7 @@
                   <a:t>‘</a:t>
                 </a:r>
                 <a:r>
-                  <a:rPr lang="de-DE" sz="1400" dirty="0">
+                  <a:rPr lang="de-DE" sz="1100" dirty="0">
                     <a:solidFill>
                       <a:schemeClr val="tx1"/>
                     </a:solidFill>
@@ -4933,7 +4933,7 @@
                   <a:t>] </a:t>
                 </a:r>
                 <a:r>
-                  <a:rPr lang="de-DE" sz="1400" dirty="0">
+                  <a:rPr lang="de-DE" sz="1100" dirty="0">
                     <a:solidFill>
                       <a:schemeClr val="tx1"/>
                     </a:solidFill>
@@ -4941,7 +4941,7 @@
                   <a:t>→</a:t>
                 </a:r>
                 <a:r>
-                  <a:rPr lang="de-DE" sz="1400" dirty="0">
+                  <a:rPr lang="de-DE" sz="1100" dirty="0">
                     <a:solidFill>
                       <a:schemeClr val="tx1"/>
                     </a:solidFill>
@@ -4950,7 +4950,7 @@
                   <a:t> [</a:t>
                 </a:r>
                 <a:r>
-                  <a:rPr lang="de-DE" sz="1400" dirty="0">
+                  <a:rPr lang="de-DE" sz="1100" dirty="0">
                     <a:solidFill>
                       <a:schemeClr val="tx1"/>
                     </a:solidFill>
@@ -4958,7 +4958,7 @@
                   <a:t>'</a:t>
                 </a:r>
                 <a:r>
-                  <a:rPr lang="de-DE" sz="1400" dirty="0" err="1">
+                  <a:rPr lang="de-DE" sz="1100" dirty="0" err="1">
                     <a:solidFill>
                       <a:schemeClr val="tx1"/>
                     </a:solidFill>
@@ -4966,7 +4966,7 @@
                   <a:t>wine</a:t>
                 </a:r>
                 <a:r>
-                  <a:rPr lang="de-DE" sz="1400" dirty="0">
+                  <a:rPr lang="de-DE" sz="1100" dirty="0">
                     <a:solidFill>
                       <a:schemeClr val="tx1"/>
                     </a:solidFill>
@@ -4974,7 +4974,7 @@
                   <a:t>', '</a:t>
                 </a:r>
                 <a:r>
-                  <a:rPr lang="de-DE" sz="1400" dirty="0" err="1">
+                  <a:rPr lang="de-DE" sz="1100" dirty="0" err="1">
                     <a:solidFill>
                       <a:schemeClr val="tx1"/>
                     </a:solidFill>
@@ -4982,7 +4982,7 @@
                   <a:t>chocolate</a:t>
                 </a:r>
                 <a:r>
-                  <a:rPr lang="de-DE" sz="1400" dirty="0">
+                  <a:rPr lang="de-DE" sz="1100" dirty="0">
                     <a:solidFill>
                       <a:schemeClr val="tx1"/>
                     </a:solidFill>
@@ -4990,7 +4990,7 @@
                   <a:t>'</a:t>
                 </a:r>
                 <a:r>
-                  <a:rPr lang="de-DE" sz="1400" dirty="0">
+                  <a:rPr lang="de-DE" sz="1100" dirty="0">
                     <a:solidFill>
                       <a:schemeClr val="tx1"/>
                     </a:solidFill>
@@ -4998,7 +4998,7 @@
                   </a:rPr>
                   <a:t>]</a:t>
                 </a:r>
-                <a:endParaRPr lang="de-DE" dirty="0">
+                <a:endParaRPr lang="de-DE" sz="1400" dirty="0">
                   <a:cs typeface="Times New Roman" panose="02020603050405020304" pitchFamily="18" charset="0"/>
                 </a:endParaRPr>
               </a:p>
@@ -5085,7 +5085,7 @@
               <a:p>
                 <a:pPr algn="ctr"/>
                 <a:r>
-                  <a:rPr lang="de-DE" b="1" dirty="0">
+                  <a:rPr lang="de-DE" sz="1400" b="1" dirty="0">
                     <a:solidFill>
                       <a:schemeClr val="tx1"/>
                     </a:solidFill>
@@ -5143,7 +5143,7 @@
               <a:lstStyle/>
               <a:p>
                 <a:r>
-                  <a:rPr lang="de-DE" dirty="0">
+                  <a:rPr lang="de-DE" sz="1400" dirty="0">
                     <a:solidFill>
                       <a:schemeClr val="tx1"/>
                     </a:solidFill>
@@ -5152,7 +5152,7 @@
                   <a:t>Word </a:t>
                 </a:r>
                 <a:r>
-                  <a:rPr lang="de-DE" dirty="0" err="1">
+                  <a:rPr lang="de-DE" sz="1400" dirty="0" err="1">
                     <a:solidFill>
                       <a:schemeClr val="tx1"/>
                     </a:solidFill>
@@ -5160,7 +5160,7 @@
                   </a:rPr>
                   <a:t>stemming</a:t>
                 </a:r>
-                <a:endParaRPr lang="de-DE" dirty="0">
+                <a:endParaRPr lang="de-DE" sz="1400" dirty="0">
                   <a:solidFill>
                     <a:schemeClr val="tx1"/>
                   </a:solidFill>
@@ -5169,7 +5169,7 @@
               </a:p>
               <a:p>
                 <a:r>
-                  <a:rPr lang="de-DE" sz="1400" dirty="0">
+                  <a:rPr lang="de-DE" sz="1100" dirty="0">
                     <a:solidFill>
                       <a:schemeClr val="tx1"/>
                     </a:solidFill>
@@ -5178,7 +5178,7 @@
                   <a:t>Example: </a:t>
                 </a:r>
                 <a:r>
-                  <a:rPr lang="de-DE" sz="1400" dirty="0" err="1">
+                  <a:rPr lang="de-DE" sz="1100" dirty="0" err="1">
                     <a:solidFill>
                       <a:schemeClr val="tx1"/>
                     </a:solidFill>
@@ -5187,7 +5187,7 @@
                   <a:t>deliveries</a:t>
                 </a:r>
                 <a:r>
-                  <a:rPr lang="de-DE" sz="1400" dirty="0">
+                  <a:rPr lang="de-DE" sz="1100" dirty="0">
                     <a:solidFill>
                       <a:schemeClr val="tx1"/>
                     </a:solidFill>
@@ -5196,7 +5196,7 @@
                   <a:t> </a:t>
                 </a:r>
                 <a:r>
-                  <a:rPr lang="de-DE" sz="1400" dirty="0">
+                  <a:rPr lang="de-DE" sz="1100" dirty="0">
                     <a:solidFill>
                       <a:schemeClr val="tx1"/>
                     </a:solidFill>
@@ -5204,7 +5204,7 @@
                   <a:t>→ </a:t>
                 </a:r>
                 <a:r>
-                  <a:rPr lang="de-DE" sz="1400" dirty="0" err="1">
+                  <a:rPr lang="de-DE" sz="1100" dirty="0" err="1">
                     <a:solidFill>
                       <a:schemeClr val="tx1"/>
                     </a:solidFill>
@@ -5212,7 +5212,7 @@
                   <a:t>deliveri</a:t>
                 </a:r>
                 <a:r>
-                  <a:rPr lang="de-DE" sz="1400" dirty="0">
+                  <a:rPr lang="de-DE" sz="1100" dirty="0">
                     <a:solidFill>
                       <a:schemeClr val="tx1"/>
                     </a:solidFill>
@@ -5220,7 +5220,7 @@
                   </a:rPr>
                   <a:t> </a:t>
                 </a:r>
-                <a:endParaRPr lang="de-DE" sz="1400" dirty="0">
+                <a:endParaRPr lang="de-DE" sz="1100" dirty="0">
                   <a:cs typeface="Times New Roman" panose="02020603050405020304" pitchFamily="18" charset="0"/>
                 </a:endParaRPr>
               </a:p>
@@ -5307,7 +5307,7 @@
               <a:p>
                 <a:pPr algn="ctr"/>
                 <a:r>
-                  <a:rPr lang="de-DE" b="1" dirty="0">
+                  <a:rPr lang="de-DE" sz="1400" b="1" dirty="0">
                     <a:solidFill>
                       <a:schemeClr val="tx1"/>
                     </a:solidFill>
@@ -5365,7 +5365,7 @@
               <a:lstStyle/>
               <a:p>
                 <a:r>
-                  <a:rPr lang="de-DE" dirty="0">
+                  <a:rPr lang="de-DE" sz="1400" dirty="0">
                     <a:solidFill>
                       <a:schemeClr val="tx1"/>
                     </a:solidFill>
@@ -5374,7 +5374,7 @@
                   <a:t>Join </a:t>
                 </a:r>
                 <a:r>
-                  <a:rPr lang="de-DE" dirty="0" err="1">
+                  <a:rPr lang="de-DE" sz="1400" dirty="0" err="1">
                     <a:solidFill>
                       <a:schemeClr val="tx1"/>
                     </a:solidFill>
@@ -5383,7 +5383,7 @@
                   <a:t>word</a:t>
                 </a:r>
                 <a:r>
-                  <a:rPr lang="de-DE" dirty="0">
+                  <a:rPr lang="de-DE" sz="1400" dirty="0">
                     <a:solidFill>
                       <a:schemeClr val="tx1"/>
                     </a:solidFill>
@@ -5392,7 +5392,7 @@
                   <a:t> </a:t>
                 </a:r>
                 <a:r>
-                  <a:rPr lang="de-DE" dirty="0" err="1">
+                  <a:rPr lang="de-DE" sz="1400" dirty="0" err="1">
                     <a:solidFill>
                       <a:schemeClr val="tx1"/>
                     </a:solidFill>
@@ -5400,7 +5400,7 @@
                   </a:rPr>
                   <a:t>stems</a:t>
                 </a:r>
-                <a:endParaRPr lang="de-DE" dirty="0">
+                <a:endParaRPr lang="de-DE" sz="1400" dirty="0">
                   <a:solidFill>
                     <a:schemeClr val="tx1"/>
                   </a:solidFill>
@@ -5409,7 +5409,7 @@
               </a:p>
               <a:p>
                 <a:r>
-                  <a:rPr lang="de-DE" sz="1400" dirty="0">
+                  <a:rPr lang="de-DE" sz="1100" dirty="0">
                     <a:solidFill>
                       <a:schemeClr val="tx1"/>
                     </a:solidFill>
@@ -5418,7 +5418,7 @@
                   <a:t>Example: [</a:t>
                 </a:r>
                 <a:r>
-                  <a:rPr lang="de-DE" sz="1400" dirty="0">
+                  <a:rPr lang="de-DE" sz="1100" dirty="0">
                     <a:solidFill>
                       <a:schemeClr val="tx1"/>
                     </a:solidFill>
@@ -5426,7 +5426,7 @@
                   <a:t>'</a:t>
                 </a:r>
                 <a:r>
-                  <a:rPr lang="de-DE" sz="1400" dirty="0" err="1">
+                  <a:rPr lang="de-DE" sz="1100" dirty="0" err="1">
                     <a:solidFill>
                       <a:schemeClr val="tx1"/>
                     </a:solidFill>
@@ -5434,7 +5434,7 @@
                   <a:t>deliveri</a:t>
                 </a:r>
                 <a:r>
-                  <a:rPr lang="de-DE" sz="1400" dirty="0">
+                  <a:rPr lang="de-DE" sz="1100" dirty="0">
                     <a:solidFill>
                       <a:schemeClr val="tx1"/>
                     </a:solidFill>
@@ -5442,7 +5442,7 @@
                   <a:t>', 'date', 'miss‘</a:t>
                 </a:r>
                 <a:r>
-                  <a:rPr lang="de-DE" sz="1400" dirty="0">
+                  <a:rPr lang="de-DE" sz="1100" dirty="0">
                     <a:solidFill>
                       <a:schemeClr val="tx1"/>
                     </a:solidFill>
@@ -5451,7 +5451,7 @@
                   <a:t>] </a:t>
                 </a:r>
                 <a:r>
-                  <a:rPr lang="de-DE" sz="1400" dirty="0">
+                  <a:rPr lang="de-DE" sz="1100" dirty="0">
                     <a:solidFill>
                       <a:schemeClr val="tx1"/>
                     </a:solidFill>
@@ -5459,7 +5459,7 @@
                   <a:t>→</a:t>
                 </a:r>
                 <a:r>
-                  <a:rPr lang="de-DE" sz="1400" dirty="0">
+                  <a:rPr lang="de-DE" sz="1100" dirty="0">
                     <a:solidFill>
                       <a:schemeClr val="tx1"/>
                     </a:solidFill>
@@ -5468,7 +5468,7 @@
                   <a:t> [</a:t>
                 </a:r>
                 <a:r>
-                  <a:rPr lang="de-DE" sz="1400" dirty="0">
+                  <a:rPr lang="de-DE" sz="1100" dirty="0">
                     <a:solidFill>
                       <a:schemeClr val="tx1"/>
                     </a:solidFill>
@@ -5476,7 +5476,7 @@
                   <a:t>'</a:t>
                 </a:r>
                 <a:r>
-                  <a:rPr lang="de-DE" sz="1400" dirty="0" err="1">
+                  <a:rPr lang="de-DE" sz="1100" dirty="0" err="1">
                     <a:solidFill>
                       <a:schemeClr val="tx1"/>
                     </a:solidFill>
@@ -5484,7 +5484,7 @@
                   <a:t>deliveri</a:t>
                 </a:r>
                 <a:r>
-                  <a:rPr lang="de-DE" sz="1400" dirty="0">
+                  <a:rPr lang="de-DE" sz="1100" dirty="0">
                     <a:solidFill>
                       <a:schemeClr val="tx1"/>
                     </a:solidFill>
@@ -5492,7 +5492,7 @@
                   <a:t> date miss'</a:t>
                 </a:r>
                 <a:r>
-                  <a:rPr lang="de-DE" sz="1400" dirty="0">
+                  <a:rPr lang="de-DE" sz="1100" dirty="0">
                     <a:solidFill>
                       <a:schemeClr val="tx1"/>
                     </a:solidFill>
@@ -5500,7 +5500,7 @@
                   </a:rPr>
                   <a:t>] </a:t>
                 </a:r>
-                <a:endParaRPr lang="de-DE" sz="1400" dirty="0">
+                <a:endParaRPr lang="de-DE" sz="1100" dirty="0">
                   <a:cs typeface="Times New Roman" panose="02020603050405020304" pitchFamily="18" charset="0"/>
                 </a:endParaRPr>
               </a:p>
@@ -5587,7 +5587,7 @@
               <a:p>
                 <a:pPr algn="ctr"/>
                 <a:r>
-                  <a:rPr lang="de-DE" b="1" dirty="0">
+                  <a:rPr lang="de-DE" sz="1400" b="1" dirty="0">
                     <a:solidFill>
                       <a:schemeClr val="tx1"/>
                     </a:solidFill>
@@ -5645,7 +5645,7 @@
               <a:lstStyle/>
               <a:p>
                 <a:r>
-                  <a:rPr lang="de-DE" dirty="0">
+                  <a:rPr lang="de-DE" sz="1400" dirty="0">
                     <a:solidFill>
                       <a:schemeClr val="tx1"/>
                     </a:solidFill>
@@ -5654,7 +5654,7 @@
                   <a:t>Split into </a:t>
                 </a:r>
                 <a:r>
-                  <a:rPr lang="de-DE" dirty="0" err="1">
+                  <a:rPr lang="de-DE" sz="1400" dirty="0" err="1">
                     <a:solidFill>
                       <a:schemeClr val="tx1"/>
                     </a:solidFill>
@@ -5662,7 +5662,7 @@
                   </a:rPr>
                   <a:t>words</a:t>
                 </a:r>
-                <a:endParaRPr lang="de-DE" dirty="0">
+                <a:endParaRPr lang="de-DE" sz="1400" dirty="0">
                   <a:solidFill>
                     <a:schemeClr val="tx1"/>
                   </a:solidFill>
@@ -5671,7 +5671,7 @@
               </a:p>
               <a:p>
                 <a:r>
-                  <a:rPr lang="de-DE" sz="1400" dirty="0">
+                  <a:rPr lang="de-DE" sz="1100" dirty="0">
                     <a:solidFill>
                       <a:schemeClr val="tx1"/>
                     </a:solidFill>
@@ -5680,7 +5680,7 @@
                   <a:t>Example: [</a:t>
                 </a:r>
                 <a:r>
-                  <a:rPr lang="de-DE" sz="1400" dirty="0">
+                  <a:rPr lang="de-DE" sz="1100" dirty="0">
                     <a:solidFill>
                       <a:schemeClr val="tx1"/>
                     </a:solidFill>
@@ -5688,7 +5688,7 @@
                   <a:t>'</a:t>
                 </a:r>
                 <a:r>
-                  <a:rPr lang="de-DE" sz="1400" dirty="0" err="1">
+                  <a:rPr lang="de-DE" sz="1100" dirty="0" err="1">
                     <a:solidFill>
                       <a:schemeClr val="tx1"/>
                     </a:solidFill>
@@ -5696,7 +5696,7 @@
                   <a:t>hello</a:t>
                 </a:r>
                 <a:r>
-                  <a:rPr lang="de-DE" sz="1400" dirty="0">
+                  <a:rPr lang="de-DE" sz="1100" dirty="0">
                     <a:solidFill>
                       <a:schemeClr val="tx1"/>
                     </a:solidFill>
@@ -5704,7 +5704,7 @@
                   <a:t> there'</a:t>
                 </a:r>
                 <a:r>
-                  <a:rPr lang="de-DE" sz="1400" dirty="0">
+                  <a:rPr lang="de-DE" sz="1100" dirty="0">
                     <a:solidFill>
                       <a:schemeClr val="tx1"/>
                     </a:solidFill>
@@ -5713,7 +5713,7 @@
                   <a:t>]</a:t>
                 </a:r>
                 <a:r>
-                  <a:rPr lang="de-DE" sz="1400" dirty="0">
+                  <a:rPr lang="de-DE" sz="1100" dirty="0">
                     <a:solidFill>
                       <a:schemeClr val="tx1"/>
                     </a:solidFill>
@@ -5721,7 +5721,7 @@
                   <a:t> →</a:t>
                 </a:r>
                 <a:r>
-                  <a:rPr lang="de-DE" sz="1400" dirty="0">
+                  <a:rPr lang="de-DE" sz="1100" dirty="0">
                     <a:solidFill>
                       <a:schemeClr val="tx1"/>
                     </a:solidFill>
@@ -5730,7 +5730,7 @@
                   <a:t> [</a:t>
                 </a:r>
                 <a:r>
-                  <a:rPr lang="de-DE" sz="1400" dirty="0">
+                  <a:rPr lang="de-DE" sz="1100" dirty="0">
                     <a:solidFill>
                       <a:schemeClr val="tx1"/>
                     </a:solidFill>
@@ -5738,7 +5738,7 @@
                   <a:t>'</a:t>
                 </a:r>
                 <a:r>
-                  <a:rPr lang="de-DE" sz="1400" dirty="0" err="1">
+                  <a:rPr lang="de-DE" sz="1100" dirty="0" err="1">
                     <a:solidFill>
                       <a:schemeClr val="tx1"/>
                     </a:solidFill>
@@ -5746,7 +5746,7 @@
                   <a:t>hello</a:t>
                 </a:r>
                 <a:r>
-                  <a:rPr lang="de-DE" sz="1400" dirty="0">
+                  <a:rPr lang="de-DE" sz="1100" dirty="0">
                     <a:solidFill>
                       <a:schemeClr val="tx1"/>
                     </a:solidFill>
@@ -5754,7 +5754,7 @@
                   <a:t>', 'there'</a:t>
                 </a:r>
                 <a:r>
-                  <a:rPr lang="de-DE" sz="1400" dirty="0">
+                  <a:rPr lang="de-DE" sz="1100" dirty="0">
                     <a:solidFill>
                       <a:schemeClr val="tx1"/>
                     </a:solidFill>
@@ -5762,7 +5762,7 @@
                   </a:rPr>
                   <a:t>]</a:t>
                 </a:r>
-                <a:endParaRPr lang="de-DE" dirty="0">
+                <a:endParaRPr lang="de-DE" sz="1400" dirty="0">
                   <a:cs typeface="Times New Roman" panose="02020603050405020304" pitchFamily="18" charset="0"/>
                 </a:endParaRPr>
               </a:p>
@@ -5849,7 +5849,7 @@
               <a:p>
                 <a:pPr algn="ctr"/>
                 <a:r>
-                  <a:rPr lang="de-DE" b="1" dirty="0">
+                  <a:rPr lang="de-DE" sz="1400" b="1" dirty="0">
                     <a:solidFill>
                       <a:schemeClr val="tx1"/>
                     </a:solidFill>
@@ -5907,7 +5907,7 @@
               <a:lstStyle/>
               <a:p>
                 <a:r>
-                  <a:rPr lang="de-DE" dirty="0">
+                  <a:rPr lang="de-DE" sz="1400" dirty="0">
                     <a:solidFill>
                       <a:schemeClr val="tx1"/>
                     </a:solidFill>
@@ -5916,7 +5916,7 @@
                   <a:t>Create </a:t>
                 </a:r>
                 <a:r>
-                  <a:rPr lang="de-DE" dirty="0" err="1">
+                  <a:rPr lang="de-DE" sz="1400" dirty="0" err="1">
                     <a:solidFill>
                       <a:schemeClr val="tx1"/>
                     </a:solidFill>
@@ -5925,7 +5925,7 @@
                   <a:t>star</a:t>
                 </a:r>
                 <a:r>
-                  <a:rPr lang="de-DE" dirty="0">
+                  <a:rPr lang="de-DE" sz="1400" dirty="0">
                     <a:solidFill>
                       <a:schemeClr val="tx1"/>
                     </a:solidFill>
@@ -5934,7 +5934,7 @@
                   <a:t> </a:t>
                 </a:r>
                 <a:r>
-                  <a:rPr lang="de-DE" dirty="0" err="1">
+                  <a:rPr lang="de-DE" sz="1400" dirty="0" err="1">
                     <a:solidFill>
                       <a:schemeClr val="tx1"/>
                     </a:solidFill>
@@ -5943,7 +5943,7 @@
                   <a:t>rating</a:t>
                 </a:r>
                 <a:r>
-                  <a:rPr lang="de-DE" dirty="0">
+                  <a:rPr lang="de-DE" sz="1400" dirty="0">
                     <a:solidFill>
                       <a:schemeClr val="tx1"/>
                     </a:solidFill>
@@ -5952,7 +5952,7 @@
                   <a:t> </a:t>
                 </a:r>
                 <a:r>
-                  <a:rPr lang="de-DE" dirty="0" err="1">
+                  <a:rPr lang="de-DE" sz="1400" dirty="0" err="1">
                     <a:solidFill>
                       <a:schemeClr val="tx1"/>
                     </a:solidFill>
@@ -5960,7 +5960,7 @@
                   </a:rPr>
                   <a:t>classes</a:t>
                 </a:r>
-                <a:endParaRPr lang="de-DE" dirty="0">
+                <a:endParaRPr lang="de-DE" sz="1400" dirty="0">
                   <a:solidFill>
                     <a:schemeClr val="tx1"/>
                   </a:solidFill>
@@ -5969,7 +5969,7 @@
               </a:p>
               <a:p>
                 <a:r>
-                  <a:rPr lang="de-DE" sz="1400" dirty="0">
+                  <a:rPr lang="de-DE" sz="1100" dirty="0">
                     <a:solidFill>
                       <a:schemeClr val="tx1"/>
                     </a:solidFill>
@@ -5978,14 +5978,14 @@
                   <a:t>Example: 2 </a:t>
                 </a:r>
                 <a:r>
-                  <a:rPr lang="de-DE" sz="1400" dirty="0">
+                  <a:rPr lang="de-DE" sz="1100" dirty="0">
                     <a:solidFill>
                       <a:schemeClr val="tx1"/>
                     </a:solidFill>
                   </a:rPr>
                   <a:t>→ 'Bad'; 3 → 'Bad'; 5 → 'Good'</a:t>
                 </a:r>
-                <a:endParaRPr lang="de-DE" sz="1400" dirty="0">
+                <a:endParaRPr lang="de-DE" sz="1100" dirty="0">
                   <a:solidFill>
                     <a:schemeClr val="tx1"/>
                   </a:solidFill>
@@ -6075,7 +6075,7 @@
               <a:p>
                 <a:pPr algn="ctr"/>
                 <a:r>
-                  <a:rPr lang="de-DE" b="1" dirty="0">
+                  <a:rPr lang="de-DE" sz="1400" b="1" dirty="0">
                     <a:solidFill>
                       <a:schemeClr val="tx1"/>
                     </a:solidFill>
@@ -6133,7 +6133,7 @@
               <a:lstStyle/>
               <a:p>
                 <a:r>
-                  <a:rPr lang="de-DE" dirty="0">
+                  <a:rPr lang="de-DE" sz="1400" dirty="0">
                     <a:solidFill>
                       <a:schemeClr val="tx1"/>
                     </a:solidFill>
@@ -6142,7 +6142,7 @@
                   <a:t>Create </a:t>
                 </a:r>
                 <a:r>
-                  <a:rPr lang="de-DE" dirty="0" err="1">
+                  <a:rPr lang="de-DE" sz="1400" dirty="0" err="1">
                     <a:solidFill>
                       <a:schemeClr val="tx1"/>
                     </a:solidFill>
@@ -6151,7 +6151,7 @@
                   <a:t>dataset</a:t>
                 </a:r>
                 <a:r>
-                  <a:rPr lang="de-DE" dirty="0">
+                  <a:rPr lang="de-DE" sz="1400" dirty="0">
                     <a:solidFill>
                       <a:schemeClr val="tx1"/>
                     </a:solidFill>
@@ -6160,7 +6160,7 @@
                   <a:t> with </a:t>
                 </a:r>
                 <a:r>
-                  <a:rPr lang="de-DE" dirty="0" err="1">
+                  <a:rPr lang="de-DE" sz="1400" dirty="0" err="1">
                     <a:solidFill>
                       <a:schemeClr val="tx1"/>
                     </a:solidFill>
@@ -6169,7 +6169,7 @@
                   <a:t>rating</a:t>
                 </a:r>
                 <a:r>
-                  <a:rPr lang="de-DE" dirty="0">
+                  <a:rPr lang="de-DE" sz="1400" dirty="0">
                     <a:solidFill>
                       <a:schemeClr val="tx1"/>
                     </a:solidFill>
@@ -6178,7 +6178,7 @@
                   <a:t> </a:t>
                 </a:r>
                 <a:r>
-                  <a:rPr lang="de-DE" dirty="0" err="1">
+                  <a:rPr lang="de-DE" sz="1400" dirty="0" err="1">
                     <a:solidFill>
                       <a:schemeClr val="tx1"/>
                     </a:solidFill>
@@ -6187,7 +6187,7 @@
                   <a:t>classes</a:t>
                 </a:r>
                 <a:r>
-                  <a:rPr lang="de-DE" dirty="0">
+                  <a:rPr lang="de-DE" sz="1400" dirty="0">
                     <a:solidFill>
                       <a:schemeClr val="tx1"/>
                     </a:solidFill>
@@ -6196,7 +6196,7 @@
                   <a:t> and </a:t>
                 </a:r>
                 <a:r>
-                  <a:rPr lang="de-DE" dirty="0" err="1">
+                  <a:rPr lang="de-DE" sz="1400" dirty="0" err="1">
                     <a:solidFill>
                       <a:schemeClr val="tx1"/>
                     </a:solidFill>
@@ -6205,7 +6205,7 @@
                   <a:t>word</a:t>
                 </a:r>
                 <a:r>
-                  <a:rPr lang="de-DE" dirty="0">
+                  <a:rPr lang="de-DE" sz="1400" dirty="0">
                     <a:solidFill>
                       <a:schemeClr val="tx1"/>
                     </a:solidFill>
@@ -6214,7 +6214,7 @@
                   <a:t> </a:t>
                 </a:r>
                 <a:r>
-                  <a:rPr lang="de-DE" dirty="0" err="1">
+                  <a:rPr lang="de-DE" sz="1400" dirty="0" err="1">
                     <a:solidFill>
                       <a:schemeClr val="tx1"/>
                     </a:solidFill>
@@ -6223,7 +6223,7 @@
                   <a:t>stem</a:t>
                 </a:r>
                 <a:r>
-                  <a:rPr lang="de-DE" dirty="0">
+                  <a:rPr lang="de-DE" sz="1400" dirty="0">
                     <a:solidFill>
                       <a:schemeClr val="tx1"/>
                     </a:solidFill>
@@ -6232,7 +6232,7 @@
                   <a:t> </a:t>
                 </a:r>
                 <a:r>
-                  <a:rPr lang="de-DE" dirty="0" err="1">
+                  <a:rPr lang="de-DE" sz="1400" dirty="0" err="1">
                     <a:solidFill>
                       <a:schemeClr val="tx1"/>
                     </a:solidFill>
@@ -6240,7 +6240,7 @@
                   </a:rPr>
                   <a:t>strings</a:t>
                 </a:r>
-                <a:endParaRPr lang="de-DE" dirty="0">
+                <a:endParaRPr lang="de-DE" sz="1400" dirty="0">
                   <a:solidFill>
                     <a:schemeClr val="tx1"/>
                   </a:solidFill>

</xml_diff>